<commit_message>
docs(aisan_lbo_case): respond to analytical review — cash availability, MIP, segment, print/QA polish
PPTX (19→20 slides): add "Excess Cash Is Central to Returns" slide
(cash availability 3-case + MIP dilution); soften unverified wording;
watchlist + excess-cash gate in conclusion; renumber + app.xml to 20.

Excel model (gitignored *.xlsx, not in repo): added cash-availability and
MIP sensitivity blocks to Returns, illustrative segment table to Model,
landscape fit-to-page print setup, Lev_Sensitivity formula-isation —
all recorded here for traceability.

Docs: HANDOFF §5 corrections log updated through review rounds 1-4;
PROGRESS round-4 section + latest-QA counts; FACT_CHECK visual-QA status;
deprecate one-shot update_pptx_addendum.py (moved to _archive).

Co-Authored-By: Claude Opus 4.8 <noreply@anthropic.com>
</commit_message>
<xml_diff>
--- a/aisan_lbo_case/docs/AISAN_4667_Take_Private_Case_Study.pptx
+++ b/aisan_lbo_case/docs/AISAN_4667_Take_Private_Case_Study.pptx
@@ -19,6 +19,7 @@
     <p:sldId id="266" r:id="rId12"/>
     <p:sldId id="267" r:id="rId13"/>
     <p:sldId id="274" r:id="rId25"/>
+    <p:sldId id="276" r:id="rId26"/>
     <p:sldId id="268" r:id="rId14"/>
     <p:sldId id="269" r:id="rId15"/>
     <p:sldId id="270" r:id="rId16"/>
@@ -14803,6 +14804,1805 @@
 </file>
 
 <file path=ppt/slides/slide15.xml><?xml version="1.0" encoding="utf-8"?>
+<p:sld xmlns:a="http://schemas.openxmlformats.org/drawingml/2006/main" xmlns:p="http://schemas.openxmlformats.org/presentationml/2006/main" xmlns:r="http://schemas.openxmlformats.org/officeDocument/2006/relationships">
+  <p:cSld>
+    <p:spTree>
+      <p:nvGrpSpPr>
+        <p:cNvPr id="1" name=""/>
+        <p:cNvGrpSpPr/>
+        <p:nvPr/>
+      </p:nvGrpSpPr>
+      <p:grpSpPr/>
+      <p:sp>
+        <p:nvSpPr>
+          <p:cNvPr id="2" name="TextBox 1"/>
+          <p:cNvSpPr txBox="1"/>
+          <p:nvPr/>
+        </p:nvSpPr>
+        <p:spPr>
+          <a:xfrm>
+            <a:off x="548640" y="384048"/>
+            <a:ext cx="566928" cy="365760"/>
+          </a:xfrm>
+          <a:prstGeom prst="rect">
+            <a:avLst/>
+          </a:prstGeom>
+          <a:noFill/>
+          <a:ln>
+            <a:noFill/>
+          </a:ln>
+        </p:spPr>
+        <p:txBody>
+          <a:bodyPr wrap="square" lIns="73152" rIns="73152" tIns="36576" bIns="36576" anchor="ctr">
+            <a:noAutofit/>
+          </a:bodyPr>
+          <a:lstStyle/>
+          <a:p>
+            <a:pPr algn="l"/>
+            <a:r>
+              <a:rPr sz="1500" b="1">
+                <a:solidFill>
+                  <a:srgbClr val="C8A951"/>
+                </a:solidFill>
+                <a:latin typeface="Georgia"/>
+              </a:rPr>
+              <a:t>14</a:t>
+            </a:r>
+          </a:p>
+        </p:txBody>
+      </p:sp>
+      <p:sp>
+        <p:nvSpPr>
+          <p:cNvPr id="3" name="TextBox 2"/>
+          <p:cNvSpPr txBox="1"/>
+          <p:nvPr/>
+        </p:nvSpPr>
+        <p:spPr>
+          <a:xfrm>
+            <a:off x="1078992" y="274320"/>
+            <a:ext cx="8778240" cy="502920"/>
+          </a:xfrm>
+          <a:prstGeom prst="rect">
+            <a:avLst/>
+          </a:prstGeom>
+          <a:noFill/>
+        </p:spPr>
+        <p:txBody>
+          <a:bodyPr wrap="square" lIns="73152" rIns="73152" tIns="36576" bIns="36576" anchor="t">
+            <a:noAutofit/>
+          </a:bodyPr>
+          <a:lstStyle/>
+          <a:p>
+            <a:pPr algn="l"/>
+            <a:r>
+              <a:rPr sz="2400" b="1">
+                <a:solidFill>
+                  <a:srgbClr val="1E2761"/>
+                </a:solidFill>
+                <a:latin typeface="Georgia"/>
+              </a:rPr>
+              <a:t>Excess Cash Is Central to Returns</a:t>
+            </a:r>
+          </a:p>
+        </p:txBody>
+      </p:sp>
+      <p:sp>
+        <p:nvSpPr>
+          <p:cNvPr id="4" name="TextBox 3"/>
+          <p:cNvSpPr txBox="1"/>
+          <p:nvPr/>
+        </p:nvSpPr>
+        <p:spPr>
+          <a:xfrm>
+            <a:off x="1097280" y="777240"/>
+            <a:ext cx="10424160" cy="274320"/>
+          </a:xfrm>
+          <a:prstGeom prst="rect">
+            <a:avLst/>
+          </a:prstGeom>
+          <a:noFill/>
+        </p:spPr>
+        <p:txBody>
+          <a:bodyPr wrap="square" lIns="73152" rIns="73152" tIns="36576" bIns="36576" anchor="t">
+            <a:noAutofit/>
+          </a:bodyPr>
+          <a:lstStyle/>
+          <a:p>
+            <a:pPr algn="l"/>
+            <a:r>
+              <a:rPr sz="1100" b="0" i="1">
+                <a:solidFill>
+                  <a:srgbClr val="5B6485"/>
+                </a:solidFill>
+                <a:latin typeface="Calibri"/>
+              </a:rPr>
+              <a:t>Base case assumes extraction; returns fall sharply if cash is retained or trapped — a DD item, not underwritten</a:t>
+            </a:r>
+          </a:p>
+        </p:txBody>
+      </p:sp>
+      <p:sp>
+        <p:nvSpPr>
+          <p:cNvPr id="6" name="Rectangle 5"/>
+          <p:cNvSpPr/>
+          <p:nvPr/>
+        </p:nvSpPr>
+        <p:spPr>
+          <a:xfrm>
+            <a:off x="502920" y="1097280"/>
+            <a:ext cx="5349240" cy="292608"/>
+          </a:xfrm>
+          <a:prstGeom prst="rect">
+            <a:avLst/>
+          </a:prstGeom>
+          <a:solidFill>
+            <a:srgbClr val="1F4E79"/>
+          </a:solidFill>
+          <a:ln>
+            <a:solidFill>
+              <a:srgbClr val="1F4E79"/>
+            </a:solidFill>
+          </a:ln>
+        </p:spPr>
+        <p:style>
+          <a:lnRef idx="1">
+            <a:schemeClr val="accent1"/>
+          </a:lnRef>
+          <a:fillRef idx="3">
+            <a:schemeClr val="accent1"/>
+          </a:fillRef>
+          <a:effectRef idx="2">
+            <a:schemeClr val="accent1"/>
+          </a:effectRef>
+          <a:fontRef idx="minor">
+            <a:schemeClr val="lt1"/>
+          </a:fontRef>
+        </p:style>
+        <p:txBody>
+          <a:bodyPr rtlCol="0" anchor="ctr"/>
+          <a:lstStyle/>
+          <a:p>
+            <a:pPr algn="ctr"/>
+          </a:p>
+        </p:txBody>
+      </p:sp>
+      <p:sp>
+        <p:nvSpPr>
+          <p:cNvPr id="7" name="TextBox 6"/>
+          <p:cNvSpPr txBox="1"/>
+          <p:nvPr/>
+        </p:nvSpPr>
+        <p:spPr>
+          <a:xfrm>
+            <a:off x="539496" y="1129284"/>
+            <a:ext cx="5276088" cy="201168"/>
+          </a:xfrm>
+          <a:prstGeom prst="rect">
+            <a:avLst/>
+          </a:prstGeom>
+          <a:noFill/>
+        </p:spPr>
+        <p:txBody>
+          <a:bodyPr wrap="none" lIns="18288" rIns="18288" tIns="36576" bIns="36576" anchor="ctr">
+            <a:spAutoFit/>
+          </a:bodyPr>
+          <a:lstStyle/>
+          <a:p>
+            <a:pPr algn="l"/>
+            <a:r>
+              <a:rPr sz="850" b="1">
+                <a:solidFill>
+                  <a:srgbClr val="FFFFFF"/>
+                </a:solidFill>
+                <a:latin typeface="Aptos"/>
+              </a:rPr>
+              <a:t>Cash availability cases &amp; MIP dilution</a:t>
+            </a:r>
+          </a:p>
+        </p:txBody>
+      </p:sp>
+      <p:sp>
+        <p:nvSpPr>
+          <p:cNvPr id="8" name="Rectangle 7"/>
+          <p:cNvSpPr/>
+          <p:nvPr/>
+        </p:nvSpPr>
+        <p:spPr>
+          <a:xfrm>
+            <a:off x="685800" y="1536192"/>
+            <a:ext cx="1417320" cy="960120"/>
+          </a:xfrm>
+          <a:prstGeom prst="rect">
+            <a:avLst/>
+          </a:prstGeom>
+          <a:solidFill>
+            <a:srgbClr val="FFFFFF"/>
+          </a:solidFill>
+          <a:ln>
+            <a:solidFill>
+              <a:srgbClr val="D8DEE4"/>
+            </a:solidFill>
+          </a:ln>
+        </p:spPr>
+        <p:style>
+          <a:lnRef idx="1">
+            <a:schemeClr val="accent1"/>
+          </a:lnRef>
+          <a:fillRef idx="3">
+            <a:schemeClr val="accent1"/>
+          </a:fillRef>
+          <a:effectRef idx="2">
+            <a:schemeClr val="accent1"/>
+          </a:effectRef>
+          <a:fontRef idx="minor">
+            <a:schemeClr val="lt1"/>
+          </a:fontRef>
+        </p:style>
+        <p:txBody>
+          <a:bodyPr rtlCol="0" anchor="ctr"/>
+          <a:lstStyle/>
+          <a:p>
+            <a:pPr algn="ctr"/>
+          </a:p>
+        </p:txBody>
+      </p:sp>
+      <p:sp>
+        <p:nvSpPr>
+          <p:cNvPr id="9" name="TextBox 8"/>
+          <p:cNvSpPr txBox="1"/>
+          <p:nvPr/>
+        </p:nvSpPr>
+        <p:spPr>
+          <a:xfrm>
+            <a:off x="758952" y="1609344"/>
+            <a:ext cx="1271016" cy="182880"/>
+          </a:xfrm>
+          <a:prstGeom prst="rect">
+            <a:avLst/>
+          </a:prstGeom>
+          <a:noFill/>
+        </p:spPr>
+        <p:txBody>
+          <a:bodyPr wrap="none" lIns="73152" rIns="73152" tIns="36576" bIns="36576" anchor="t">
+            <a:spAutoFit/>
+          </a:bodyPr>
+          <a:lstStyle/>
+          <a:p>
+            <a:pPr algn="ctr"/>
+            <a:r>
+              <a:rPr sz="700" b="1">
+                <a:solidFill>
+                  <a:srgbClr val="5F6970"/>
+                </a:solidFill>
+                <a:latin typeface="Aptos"/>
+              </a:rPr>
+              <a:t>FULL EXTRACTION</a:t>
+            </a:r>
+          </a:p>
+        </p:txBody>
+      </p:sp>
+      <p:sp>
+        <p:nvSpPr>
+          <p:cNvPr id="10" name="TextBox 9"/>
+          <p:cNvSpPr txBox="1"/>
+          <p:nvPr/>
+        </p:nvSpPr>
+        <p:spPr>
+          <a:xfrm>
+            <a:off x="758952" y="1847088"/>
+            <a:ext cx="1271016" cy="310896"/>
+          </a:xfrm>
+          <a:prstGeom prst="rect">
+            <a:avLst/>
+          </a:prstGeom>
+          <a:noFill/>
+        </p:spPr>
+        <p:txBody>
+          <a:bodyPr wrap="none" lIns="73152" rIns="73152" tIns="36576" bIns="36576" anchor="t">
+            <a:spAutoFit/>
+          </a:bodyPr>
+          <a:lstStyle/>
+          <a:p>
+            <a:pPr algn="ctr"/>
+            <a:r>
+              <a:rPr sz="1550" b="1">
+                <a:solidFill>
+                  <a:srgbClr val="1E2761"/>
+                </a:solidFill>
+                <a:latin typeface="Aptos"/>
+              </a:rPr>
+              <a:t>15.6%</a:t>
+            </a:r>
+          </a:p>
+        </p:txBody>
+      </p:sp>
+      <p:sp>
+        <p:nvSpPr>
+          <p:cNvPr id="11" name="TextBox 10"/>
+          <p:cNvSpPr txBox="1"/>
+          <p:nvPr/>
+        </p:nvSpPr>
+        <p:spPr>
+          <a:xfrm>
+            <a:off x="758952" y="2231136"/>
+            <a:ext cx="1271016" cy="256032"/>
+          </a:xfrm>
+          <a:prstGeom prst="rect">
+            <a:avLst/>
+          </a:prstGeom>
+          <a:noFill/>
+        </p:spPr>
+        <p:txBody>
+          <a:bodyPr wrap="none" lIns="73152" rIns="73152" tIns="36576" bIns="36576" anchor="t">
+            <a:spAutoFit/>
+          </a:bodyPr>
+          <a:lstStyle/>
+          <a:p>
+            <a:pPr algn="ctr"/>
+            <a:r>
+              <a:rPr sz="700" b="0">
+                <a:solidFill>
+                  <a:srgbClr val="5F6970"/>
+                </a:solidFill>
+                <a:latin typeface="Aptos"/>
+              </a:rPr>
+              <a:t>base case · 2.07x</a:t>
+            </a:r>
+          </a:p>
+        </p:txBody>
+      </p:sp>
+      <p:sp>
+        <p:nvSpPr>
+          <p:cNvPr id="12" name="Rectangle 11"/>
+          <p:cNvSpPr/>
+          <p:nvPr/>
+        </p:nvSpPr>
+        <p:spPr>
+          <a:xfrm>
+            <a:off x="2267712" y="1536192"/>
+            <a:ext cx="1417320" cy="960120"/>
+          </a:xfrm>
+          <a:prstGeom prst="rect">
+            <a:avLst/>
+          </a:prstGeom>
+          <a:solidFill>
+            <a:srgbClr val="FFFFFF"/>
+          </a:solidFill>
+          <a:ln>
+            <a:solidFill>
+              <a:srgbClr val="D8DEE4"/>
+            </a:solidFill>
+          </a:ln>
+        </p:spPr>
+        <p:style>
+          <a:lnRef idx="1">
+            <a:schemeClr val="accent1"/>
+          </a:lnRef>
+          <a:fillRef idx="3">
+            <a:schemeClr val="accent1"/>
+          </a:fillRef>
+          <a:effectRef idx="2">
+            <a:schemeClr val="accent1"/>
+          </a:effectRef>
+          <a:fontRef idx="minor">
+            <a:schemeClr val="lt1"/>
+          </a:fontRef>
+        </p:style>
+        <p:txBody>
+          <a:bodyPr rtlCol="0" anchor="ctr"/>
+          <a:lstStyle/>
+          <a:p>
+            <a:pPr algn="ctr"/>
+          </a:p>
+        </p:txBody>
+      </p:sp>
+      <p:sp>
+        <p:nvSpPr>
+          <p:cNvPr id="13" name="TextBox 12"/>
+          <p:cNvSpPr txBox="1"/>
+          <p:nvPr/>
+        </p:nvSpPr>
+        <p:spPr>
+          <a:xfrm>
+            <a:off x="2340864" y="1609344"/>
+            <a:ext cx="1271016" cy="182880"/>
+          </a:xfrm>
+          <a:prstGeom prst="rect">
+            <a:avLst/>
+          </a:prstGeom>
+          <a:noFill/>
+        </p:spPr>
+        <p:txBody>
+          <a:bodyPr wrap="none" lIns="73152" rIns="73152" tIns="36576" bIns="36576" anchor="t">
+            <a:spAutoFit/>
+          </a:bodyPr>
+          <a:lstStyle/>
+          <a:p>
+            <a:pPr algn="ctr"/>
+            <a:r>
+              <a:rPr sz="700" b="1">
+                <a:solidFill>
+                  <a:srgbClr val="5F6970"/>
+                </a:solidFill>
+                <a:latin typeface="Aptos"/>
+              </a:rPr>
+              <a:t>CASH RETAINED</a:t>
+            </a:r>
+          </a:p>
+        </p:txBody>
+      </p:sp>
+      <p:sp>
+        <p:nvSpPr>
+          <p:cNvPr id="14" name="TextBox 13"/>
+          <p:cNvSpPr txBox="1"/>
+          <p:nvPr/>
+        </p:nvSpPr>
+        <p:spPr>
+          <a:xfrm>
+            <a:off x="2340864" y="1847088"/>
+            <a:ext cx="1271016" cy="310896"/>
+          </a:xfrm>
+          <a:prstGeom prst="rect">
+            <a:avLst/>
+          </a:prstGeom>
+          <a:noFill/>
+        </p:spPr>
+        <p:txBody>
+          <a:bodyPr wrap="none" lIns="73152" rIns="73152" tIns="36576" bIns="36576" anchor="t">
+            <a:spAutoFit/>
+          </a:bodyPr>
+          <a:lstStyle/>
+          <a:p>
+            <a:pPr algn="ctr"/>
+            <a:r>
+              <a:rPr sz="1550" b="1">
+                <a:solidFill>
+                  <a:srgbClr val="1E2761"/>
+                </a:solidFill>
+                <a:latin typeface="Aptos"/>
+              </a:rPr>
+              <a:t>12.0%</a:t>
+            </a:r>
+          </a:p>
+        </p:txBody>
+      </p:sp>
+      <p:sp>
+        <p:nvSpPr>
+          <p:cNvPr id="15" name="TextBox 14"/>
+          <p:cNvSpPr txBox="1"/>
+          <p:nvPr/>
+        </p:nvSpPr>
+        <p:spPr>
+          <a:xfrm>
+            <a:off x="2340864" y="2231136"/>
+            <a:ext cx="1271016" cy="256032"/>
+          </a:xfrm>
+          <a:prstGeom prst="rect">
+            <a:avLst/>
+          </a:prstGeom>
+          <a:noFill/>
+        </p:spPr>
+        <p:txBody>
+          <a:bodyPr wrap="none" lIns="73152" rIns="73152" tIns="36576" bIns="36576" anchor="t">
+            <a:spAutoFit/>
+          </a:bodyPr>
+          <a:lstStyle/>
+          <a:p>
+            <a:pPr algn="ctr"/>
+            <a:r>
+              <a:rPr sz="700" b="0">
+                <a:solidFill>
+                  <a:srgbClr val="5F6970"/>
+                </a:solidFill>
+                <a:latin typeface="Aptos"/>
+              </a:rPr>
+              <a:t>sponsor funds cash · 1.76x</a:t>
+            </a:r>
+          </a:p>
+        </p:txBody>
+      </p:sp>
+      <p:sp>
+        <p:nvSpPr>
+          <p:cNvPr id="16" name="Rectangle 15"/>
+          <p:cNvSpPr/>
+          <p:nvPr/>
+        </p:nvSpPr>
+        <p:spPr>
+          <a:xfrm>
+            <a:off x="3849624" y="1536192"/>
+            <a:ext cx="1417320" cy="960120"/>
+          </a:xfrm>
+          <a:prstGeom prst="rect">
+            <a:avLst/>
+          </a:prstGeom>
+          <a:solidFill>
+            <a:srgbClr val="FFFFFF"/>
+          </a:solidFill>
+          <a:ln>
+            <a:solidFill>
+              <a:srgbClr val="D8DEE4"/>
+            </a:solidFill>
+          </a:ln>
+        </p:spPr>
+        <p:style>
+          <a:lnRef idx="1">
+            <a:schemeClr val="accent1"/>
+          </a:lnRef>
+          <a:fillRef idx="3">
+            <a:schemeClr val="accent1"/>
+          </a:fillRef>
+          <a:effectRef idx="2">
+            <a:schemeClr val="accent1"/>
+          </a:effectRef>
+          <a:fontRef idx="minor">
+            <a:schemeClr val="lt1"/>
+          </a:fontRef>
+        </p:style>
+        <p:txBody>
+          <a:bodyPr rtlCol="0" anchor="ctr"/>
+          <a:lstStyle/>
+          <a:p>
+            <a:pPr algn="ctr"/>
+          </a:p>
+        </p:txBody>
+      </p:sp>
+      <p:sp>
+        <p:nvSpPr>
+          <p:cNvPr id="17" name="TextBox 16"/>
+          <p:cNvSpPr txBox="1"/>
+          <p:nvPr/>
+        </p:nvSpPr>
+        <p:spPr>
+          <a:xfrm>
+            <a:off x="3922776" y="1609344"/>
+            <a:ext cx="1271016" cy="182880"/>
+          </a:xfrm>
+          <a:prstGeom prst="rect">
+            <a:avLst/>
+          </a:prstGeom>
+          <a:noFill/>
+        </p:spPr>
+        <p:txBody>
+          <a:bodyPr wrap="none" lIns="73152" rIns="73152" tIns="36576" bIns="36576" anchor="t">
+            <a:spAutoFit/>
+          </a:bodyPr>
+          <a:lstStyle/>
+          <a:p>
+            <a:pPr algn="ctr"/>
+            <a:r>
+              <a:rPr sz="700" b="1">
+                <a:solidFill>
+                  <a:srgbClr val="5F6970"/>
+                </a:solidFill>
+                <a:latin typeface="Aptos"/>
+              </a:rPr>
+              <a:t>TRAPPED CASH</a:t>
+            </a:r>
+          </a:p>
+        </p:txBody>
+      </p:sp>
+      <p:sp>
+        <p:nvSpPr>
+          <p:cNvPr id="18" name="TextBox 17"/>
+          <p:cNvSpPr txBox="1"/>
+          <p:nvPr/>
+        </p:nvSpPr>
+        <p:spPr>
+          <a:xfrm>
+            <a:off x="3922776" y="1847088"/>
+            <a:ext cx="1271016" cy="310896"/>
+          </a:xfrm>
+          <a:prstGeom prst="rect">
+            <a:avLst/>
+          </a:prstGeom>
+          <a:noFill/>
+        </p:spPr>
+        <p:txBody>
+          <a:bodyPr wrap="none" lIns="73152" rIns="73152" tIns="36576" bIns="36576" anchor="t">
+            <a:spAutoFit/>
+          </a:bodyPr>
+          <a:lstStyle/>
+          <a:p>
+            <a:pPr algn="ctr"/>
+            <a:r>
+              <a:rPr sz="1550" b="1">
+                <a:solidFill>
+                  <a:srgbClr val="1E2761"/>
+                </a:solidFill>
+                <a:latin typeface="Aptos"/>
+              </a:rPr>
+              <a:t>8.1%</a:t>
+            </a:r>
+          </a:p>
+        </p:txBody>
+      </p:sp>
+      <p:sp>
+        <p:nvSpPr>
+          <p:cNvPr id="19" name="TextBox 18"/>
+          <p:cNvSpPr txBox="1"/>
+          <p:nvPr/>
+        </p:nvSpPr>
+        <p:spPr>
+          <a:xfrm>
+            <a:off x="3922776" y="2231136"/>
+            <a:ext cx="1271016" cy="256032"/>
+          </a:xfrm>
+          <a:prstGeom prst="rect">
+            <a:avLst/>
+          </a:prstGeom>
+          <a:noFill/>
+        </p:spPr>
+        <p:txBody>
+          <a:bodyPr wrap="none" lIns="73152" rIns="73152" tIns="36576" bIns="36576" anchor="t">
+            <a:spAutoFit/>
+          </a:bodyPr>
+          <a:lstStyle/>
+          <a:p>
+            <a:pPr algn="ctr"/>
+            <a:r>
+              <a:rPr sz="700" b="0">
+                <a:solidFill>
+                  <a:srgbClr val="5F6970"/>
+                </a:solidFill>
+                <a:latin typeface="Aptos"/>
+              </a:rPr>
+              <a:t>unavailable · 1.47x</a:t>
+            </a:r>
+          </a:p>
+        </p:txBody>
+      </p:sp>
+      <p:graphicFrame>
+        <p:nvGraphicFramePr>
+          <p:cNvPr id="20" name="Table 19"/>
+          <p:cNvGraphicFramePr>
+            <a:graphicFrameLocks noGrp="1"/>
+          </p:cNvGraphicFramePr>
+          <p:nvPr/>
+        </p:nvGraphicFramePr>
+        <p:xfrm>
+          <a:off x="640080" y="2788920"/>
+          <a:ext cx="5029200" cy="1554480"/>
+        </p:xfrm>
+        <a:graphic>
+          <a:graphicData uri="http://schemas.openxmlformats.org/drawingml/2006/table">
+            <a:tbl>
+              <a:tblPr firstRow="1" bandRow="1">
+                <a:tableStyleId>{5C22544A-7EE6-4342-B048-85BDC9FD1C3A}</a:tableStyleId>
+              </a:tblPr>
+              <a:tblGrid>
+                <a:gridCol w="1828800"/>
+                <a:gridCol w="1600200"/>
+                <a:gridCol w="1600200"/>
+              </a:tblGrid>
+              <a:tr h="310896">
+                <a:tc>
+                  <a:txBody>
+                    <a:bodyPr/>
+                    <a:lstStyle/>
+                    <a:p>
+                      <a:pPr algn="ctr"/>
+                      <a:r>
+                        <a:rPr sz="720" b="1">
+                          <a:solidFill>
+                            <a:srgbClr val="FFFFFF"/>
+                          </a:solidFill>
+                          <a:latin typeface="Aptos"/>
+                        </a:rPr>
+                        <a:t>MIP dilution</a:t>
+                      </a:r>
+                    </a:p>
+                  </a:txBody>
+                  <a:tcPr>
+                    <a:solidFill>
+                      <a:srgbClr val="1F4E79"/>
+                    </a:solidFill>
+                  </a:tcPr>
+                </a:tc>
+                <a:tc>
+                  <a:txBody>
+                    <a:bodyPr/>
+                    <a:lstStyle/>
+                    <a:p>
+                      <a:pPr algn="ctr"/>
+                      <a:r>
+                        <a:rPr sz="720" b="1">
+                          <a:solidFill>
+                            <a:srgbClr val="FFFFFF"/>
+                          </a:solidFill>
+                          <a:latin typeface="Aptos"/>
+                        </a:rPr>
+                        <a:t>MOIC</a:t>
+                      </a:r>
+                    </a:p>
+                  </a:txBody>
+                  <a:tcPr>
+                    <a:solidFill>
+                      <a:srgbClr val="1F4E79"/>
+                    </a:solidFill>
+                  </a:tcPr>
+                </a:tc>
+                <a:tc>
+                  <a:txBody>
+                    <a:bodyPr/>
+                    <a:lstStyle/>
+                    <a:p>
+                      <a:pPr algn="ctr"/>
+                      <a:r>
+                        <a:rPr sz="720" b="1">
+                          <a:solidFill>
+                            <a:srgbClr val="FFFFFF"/>
+                          </a:solidFill>
+                          <a:latin typeface="Aptos"/>
+                        </a:rPr>
+                        <a:t>Gross IRR</a:t>
+                      </a:r>
+                    </a:p>
+                  </a:txBody>
+                  <a:tcPr>
+                    <a:solidFill>
+                      <a:srgbClr val="1F4E79"/>
+                    </a:solidFill>
+                  </a:tcPr>
+                </a:tc>
+              </a:tr>
+              <a:tr h="310896">
+                <a:tc>
+                  <a:txBody>
+                    <a:bodyPr/>
+                    <a:lstStyle/>
+                    <a:p>
+                      <a:pPr algn="l"/>
+                      <a:r>
+                        <a:rPr sz="720">
+                          <a:solidFill>
+                            <a:srgbClr val="1E2226"/>
+                          </a:solidFill>
+                          <a:latin typeface="Aptos"/>
+                        </a:rPr>
+                        <a:t>0%</a:t>
+                      </a:r>
+                    </a:p>
+                  </a:txBody>
+                  <a:tcPr marL="36576" marR="36576" marT="18288" marB="18288">
+                    <a:solidFill>
+                      <a:srgbClr val="EFF2F5"/>
+                    </a:solidFill>
+                  </a:tcPr>
+                </a:tc>
+                <a:tc>
+                  <a:txBody>
+                    <a:bodyPr/>
+                    <a:lstStyle/>
+                    <a:p>
+                      <a:pPr algn="ctr"/>
+                      <a:r>
+                        <a:rPr sz="720">
+                          <a:solidFill>
+                            <a:srgbClr val="1E2226"/>
+                          </a:solidFill>
+                          <a:latin typeface="Aptos"/>
+                        </a:rPr>
+                        <a:t>2.07x</a:t>
+                      </a:r>
+                    </a:p>
+                  </a:txBody>
+                  <a:tcPr marL="36576" marR="36576" marT="18288" marB="18288">
+                    <a:solidFill>
+                      <a:srgbClr val="EFF2F5"/>
+                    </a:solidFill>
+                  </a:tcPr>
+                </a:tc>
+                <a:tc>
+                  <a:txBody>
+                    <a:bodyPr/>
+                    <a:lstStyle/>
+                    <a:p>
+                      <a:pPr algn="ctr"/>
+                      <a:r>
+                        <a:rPr sz="720">
+                          <a:solidFill>
+                            <a:srgbClr val="1E2226"/>
+                          </a:solidFill>
+                          <a:latin typeface="Aptos"/>
+                        </a:rPr>
+                        <a:t>15.6%</a:t>
+                      </a:r>
+                    </a:p>
+                  </a:txBody>
+                  <a:tcPr marL="36576" marR="36576" marT="18288" marB="18288">
+                    <a:solidFill>
+                      <a:srgbClr val="EFF2F5"/>
+                    </a:solidFill>
+                  </a:tcPr>
+                </a:tc>
+              </a:tr>
+              <a:tr h="310896">
+                <a:tc>
+                  <a:txBody>
+                    <a:bodyPr/>
+                    <a:lstStyle/>
+                    <a:p>
+                      <a:pPr algn="l"/>
+                      <a:r>
+                        <a:rPr sz="720">
+                          <a:solidFill>
+                            <a:srgbClr val="1E2226"/>
+                          </a:solidFill>
+                          <a:latin typeface="Aptos"/>
+                        </a:rPr>
+                        <a:t>5%</a:t>
+                      </a:r>
+                    </a:p>
+                  </a:txBody>
+                  <a:tcPr marL="36576" marR="36576" marT="18288" marB="18288">
+                    <a:solidFill>
+                      <a:srgbClr val="FFFFFF"/>
+                    </a:solidFill>
+                  </a:tcPr>
+                </a:tc>
+                <a:tc>
+                  <a:txBody>
+                    <a:bodyPr/>
+                    <a:lstStyle/>
+                    <a:p>
+                      <a:pPr algn="ctr"/>
+                      <a:r>
+                        <a:rPr sz="720">
+                          <a:solidFill>
+                            <a:srgbClr val="1E2226"/>
+                          </a:solidFill>
+                          <a:latin typeface="Aptos"/>
+                        </a:rPr>
+                        <a:t>1.96x</a:t>
+                      </a:r>
+                    </a:p>
+                  </a:txBody>
+                  <a:tcPr marL="36576" marR="36576" marT="18288" marB="18288">
+                    <a:solidFill>
+                      <a:srgbClr val="FFFFFF"/>
+                    </a:solidFill>
+                  </a:tcPr>
+                </a:tc>
+                <a:tc>
+                  <a:txBody>
+                    <a:bodyPr/>
+                    <a:lstStyle/>
+                    <a:p>
+                      <a:pPr algn="ctr"/>
+                      <a:r>
+                        <a:rPr sz="720">
+                          <a:solidFill>
+                            <a:srgbClr val="1E2226"/>
+                          </a:solidFill>
+                          <a:latin typeface="Aptos"/>
+                        </a:rPr>
+                        <a:t>14.4%</a:t>
+                      </a:r>
+                    </a:p>
+                  </a:txBody>
+                  <a:tcPr marL="36576" marR="36576" marT="18288" marB="18288">
+                    <a:solidFill>
+                      <a:srgbClr val="FFFFFF"/>
+                    </a:solidFill>
+                  </a:tcPr>
+                </a:tc>
+              </a:tr>
+              <a:tr h="310896">
+                <a:tc>
+                  <a:txBody>
+                    <a:bodyPr/>
+                    <a:lstStyle/>
+                    <a:p>
+                      <a:pPr algn="l"/>
+                      <a:r>
+                        <a:rPr sz="720">
+                          <a:solidFill>
+                            <a:srgbClr val="1E2226"/>
+                          </a:solidFill>
+                          <a:latin typeface="Aptos"/>
+                        </a:rPr>
+                        <a:t>10%</a:t>
+                      </a:r>
+                    </a:p>
+                  </a:txBody>
+                  <a:tcPr marL="36576" marR="36576" marT="18288" marB="18288">
+                    <a:solidFill>
+                      <a:srgbClr val="EFF2F5"/>
+                    </a:solidFill>
+                  </a:tcPr>
+                </a:tc>
+                <a:tc>
+                  <a:txBody>
+                    <a:bodyPr/>
+                    <a:lstStyle/>
+                    <a:p>
+                      <a:pPr algn="ctr"/>
+                      <a:r>
+                        <a:rPr sz="720">
+                          <a:solidFill>
+                            <a:srgbClr val="1E2226"/>
+                          </a:solidFill>
+                          <a:latin typeface="Aptos"/>
+                        </a:rPr>
+                        <a:t>1.86x</a:t>
+                      </a:r>
+                    </a:p>
+                  </a:txBody>
+                  <a:tcPr marL="36576" marR="36576" marT="18288" marB="18288">
+                    <a:solidFill>
+                      <a:srgbClr val="EFF2F5"/>
+                    </a:solidFill>
+                  </a:tcPr>
+                </a:tc>
+                <a:tc>
+                  <a:txBody>
+                    <a:bodyPr/>
+                    <a:lstStyle/>
+                    <a:p>
+                      <a:pPr algn="ctr"/>
+                      <a:r>
+                        <a:rPr sz="720">
+                          <a:solidFill>
+                            <a:srgbClr val="1E2226"/>
+                          </a:solidFill>
+                          <a:latin typeface="Aptos"/>
+                        </a:rPr>
+                        <a:t>13.2%</a:t>
+                      </a:r>
+                    </a:p>
+                  </a:txBody>
+                  <a:tcPr marL="36576" marR="36576" marT="18288" marB="18288">
+                    <a:solidFill>
+                      <a:srgbClr val="EFF2F5"/>
+                    </a:solidFill>
+                  </a:tcPr>
+                </a:tc>
+              </a:tr>
+            </a:tbl>
+          </a:graphicData>
+        </a:graphic>
+      </p:graphicFrame>
+      <p:sp>
+        <p:nvSpPr>
+          <p:cNvPr id="21" name="TextBox 20"/>
+          <p:cNvSpPr txBox="1"/>
+          <p:nvPr/>
+        </p:nvSpPr>
+        <p:spPr>
+          <a:xfrm>
+            <a:off x="640080" y="4526280"/>
+            <a:ext cx="5029200" cy="502920"/>
+          </a:xfrm>
+          <a:prstGeom prst="rect">
+            <a:avLst/>
+          </a:prstGeom>
+          <a:noFill/>
+        </p:spPr>
+        <p:txBody>
+          <a:bodyPr wrap="square" lIns="73152" rIns="73152" tIns="36576" bIns="36576" anchor="t">
+            <a:spAutoFit/>
+          </a:bodyPr>
+          <a:lstStyle/>
+          <a:p>
+            <a:pPr algn="l"/>
+            <a:r>
+              <a:rPr sz="750" b="0">
+                <a:solidFill>
+                  <a:srgbClr val="5F6970"/>
+                </a:solidFill>
+                <a:latin typeface="Aptos"/>
+              </a:rPr>
+              <a:t>Returns are gross of fees &amp; carry; MIP dilution widens the gap to a clean 20% hurdle.</a:t>
+            </a:r>
+          </a:p>
+        </p:txBody>
+      </p:sp>
+      <p:sp>
+        <p:nvSpPr>
+          <p:cNvPr id="22" name="Rectangle 21"/>
+          <p:cNvSpPr/>
+          <p:nvPr/>
+        </p:nvSpPr>
+        <p:spPr>
+          <a:xfrm>
+            <a:off x="6126480" y="1097280"/>
+            <a:ext cx="5303520" cy="292608"/>
+          </a:xfrm>
+          <a:prstGeom prst="rect">
+            <a:avLst/>
+          </a:prstGeom>
+          <a:solidFill>
+            <a:srgbClr val="007070"/>
+          </a:solidFill>
+          <a:ln>
+            <a:solidFill>
+              <a:srgbClr val="007070"/>
+            </a:solidFill>
+          </a:ln>
+        </p:spPr>
+        <p:style>
+          <a:lnRef idx="1">
+            <a:schemeClr val="accent1"/>
+          </a:lnRef>
+          <a:fillRef idx="3">
+            <a:schemeClr val="accent1"/>
+          </a:fillRef>
+          <a:effectRef idx="2">
+            <a:schemeClr val="accent1"/>
+          </a:effectRef>
+          <a:fontRef idx="minor">
+            <a:schemeClr val="lt1"/>
+          </a:fontRef>
+        </p:style>
+        <p:txBody>
+          <a:bodyPr rtlCol="0" anchor="ctr"/>
+          <a:lstStyle/>
+          <a:p>
+            <a:pPr algn="ctr"/>
+          </a:p>
+        </p:txBody>
+      </p:sp>
+      <p:sp>
+        <p:nvSpPr>
+          <p:cNvPr id="23" name="TextBox 22"/>
+          <p:cNvSpPr txBox="1"/>
+          <p:nvPr/>
+        </p:nvSpPr>
+        <p:spPr>
+          <a:xfrm>
+            <a:off x="6163056" y="1129284"/>
+            <a:ext cx="5230368" cy="201168"/>
+          </a:xfrm>
+          <a:prstGeom prst="rect">
+            <a:avLst/>
+          </a:prstGeom>
+          <a:noFill/>
+        </p:spPr>
+        <p:txBody>
+          <a:bodyPr wrap="none" lIns="18288" rIns="18288" tIns="36576" bIns="36576" anchor="ctr">
+            <a:spAutoFit/>
+          </a:bodyPr>
+          <a:lstStyle/>
+          <a:p>
+            <a:pPr algn="l"/>
+            <a:r>
+              <a:rPr sz="850" b="1">
+                <a:solidFill>
+                  <a:srgbClr val="FFFFFF"/>
+                </a:solidFill>
+                <a:latin typeface="Aptos"/>
+              </a:rPr>
+              <a:t>Cash availability — mechanics (¥bn)</a:t>
+            </a:r>
+          </a:p>
+        </p:txBody>
+      </p:sp>
+      <p:graphicFrame>
+        <p:nvGraphicFramePr>
+          <p:cNvPr id="24" name="Table 23"/>
+          <p:cNvGraphicFramePr>
+            <a:graphicFrameLocks noGrp="1"/>
+          </p:cNvGraphicFramePr>
+          <p:nvPr/>
+        </p:nvGraphicFramePr>
+        <p:xfrm>
+          <a:off x="6236208" y="1554480"/>
+          <a:ext cx="5074920" cy="2359152"/>
+        </p:xfrm>
+        <a:graphic>
+          <a:graphicData uri="http://schemas.openxmlformats.org/drawingml/2006/table">
+            <a:tbl>
+              <a:tblPr firstRow="1" bandRow="1">
+                <a:tableStyleId>{5C22544A-7EE6-4342-B048-85BDC9FD1C3A}</a:tableStyleId>
+              </a:tblPr>
+              <a:tblGrid>
+                <a:gridCol w="1188720"/>
+                <a:gridCol w="960120"/>
+                <a:gridCol w="1051560"/>
+                <a:gridCol w="868680"/>
+                <a:gridCol w="1005840"/>
+              </a:tblGrid>
+              <a:tr h="471830">
+                <a:tc>
+                  <a:txBody>
+                    <a:bodyPr/>
+                    <a:lstStyle/>
+                    <a:p>
+                      <a:pPr algn="ctr"/>
+                      <a:r>
+                        <a:rPr sz="720" b="1">
+                          <a:solidFill>
+                            <a:srgbClr val="FFFFFF"/>
+                          </a:solidFill>
+                          <a:latin typeface="Aptos"/>
+                        </a:rPr>
+                        <a:t>Case</a:t>
+                      </a:r>
+                    </a:p>
+                  </a:txBody>
+                  <a:tcPr>
+                    <a:solidFill>
+                      <a:srgbClr val="007070"/>
+                    </a:solidFill>
+                  </a:tcPr>
+                </a:tc>
+                <a:tc>
+                  <a:txBody>
+                    <a:bodyPr/>
+                    <a:lstStyle/>
+                    <a:p>
+                      <a:pPr algn="ctr"/>
+                      <a:r>
+                        <a:rPr sz="720" b="1">
+                          <a:solidFill>
+                            <a:srgbClr val="FFFFFF"/>
+                          </a:solidFill>
+                          <a:latin typeface="Aptos"/>
+                        </a:rPr>
+                        <a:t>Sponsor eq.</a:t>
+                      </a:r>
+                    </a:p>
+                  </a:txBody>
+                  <a:tcPr>
+                    <a:solidFill>
+                      <a:srgbClr val="007070"/>
+                    </a:solidFill>
+                  </a:tcPr>
+                </a:tc>
+                <a:tc>
+                  <a:txBody>
+                    <a:bodyPr/>
+                    <a:lstStyle/>
+                    <a:p>
+                      <a:pPr algn="ctr"/>
+                      <a:r>
+                        <a:rPr sz="720" b="1">
+                          <a:solidFill>
+                            <a:srgbClr val="FFFFFF"/>
+                          </a:solidFill>
+                          <a:latin typeface="Aptos"/>
+                        </a:rPr>
+                        <a:t>Exit eq.</a:t>
+                      </a:r>
+                    </a:p>
+                  </a:txBody>
+                  <a:tcPr>
+                    <a:solidFill>
+                      <a:srgbClr val="007070"/>
+                    </a:solidFill>
+                  </a:tcPr>
+                </a:tc>
+                <a:tc>
+                  <a:txBody>
+                    <a:bodyPr/>
+                    <a:lstStyle/>
+                    <a:p>
+                      <a:pPr algn="ctr"/>
+                      <a:r>
+                        <a:rPr sz="720" b="1">
+                          <a:solidFill>
+                            <a:srgbClr val="FFFFFF"/>
+                          </a:solidFill>
+                          <a:latin typeface="Aptos"/>
+                        </a:rPr>
+                        <a:t>MOIC</a:t>
+                      </a:r>
+                    </a:p>
+                  </a:txBody>
+                  <a:tcPr>
+                    <a:solidFill>
+                      <a:srgbClr val="007070"/>
+                    </a:solidFill>
+                  </a:tcPr>
+                </a:tc>
+                <a:tc>
+                  <a:txBody>
+                    <a:bodyPr/>
+                    <a:lstStyle/>
+                    <a:p>
+                      <a:pPr algn="ctr"/>
+                      <a:r>
+                        <a:rPr sz="720" b="1">
+                          <a:solidFill>
+                            <a:srgbClr val="FFFFFF"/>
+                          </a:solidFill>
+                          <a:latin typeface="Aptos"/>
+                        </a:rPr>
+                        <a:t>IRR</a:t>
+                      </a:r>
+                    </a:p>
+                  </a:txBody>
+                  <a:tcPr>
+                    <a:solidFill>
+                      <a:srgbClr val="007070"/>
+                    </a:solidFill>
+                  </a:tcPr>
+                </a:tc>
+              </a:tr>
+              <a:tr h="471830">
+                <a:tc>
+                  <a:txBody>
+                    <a:bodyPr/>
+                    <a:lstStyle/>
+                    <a:p>
+                      <a:pPr algn="l"/>
+                      <a:r>
+                        <a:rPr sz="720">
+                          <a:solidFill>
+                            <a:srgbClr val="1E2226"/>
+                          </a:solidFill>
+                          <a:latin typeface="Aptos"/>
+                        </a:rPr>
+                        <a:t>Full extraction</a:t>
+                      </a:r>
+                    </a:p>
+                  </a:txBody>
+                  <a:tcPr marL="36576" marR="36576" marT="18288" marB="18288">
+                    <a:solidFill>
+                      <a:srgbClr val="EFF2F5"/>
+                    </a:solidFill>
+                  </a:tcPr>
+                </a:tc>
+                <a:tc>
+                  <a:txBody>
+                    <a:bodyPr/>
+                    <a:lstStyle/>
+                    <a:p>
+                      <a:pPr algn="ctr"/>
+                      <a:r>
+                        <a:rPr sz="720">
+                          <a:solidFill>
+                            <a:srgbClr val="1E2226"/>
+                          </a:solidFill>
+                          <a:latin typeface="Aptos"/>
+                        </a:rPr>
+                        <a:t>8.5</a:t>
+                      </a:r>
+                    </a:p>
+                  </a:txBody>
+                  <a:tcPr marL="36576" marR="36576" marT="18288" marB="18288">
+                    <a:solidFill>
+                      <a:srgbClr val="EFF2F5"/>
+                    </a:solidFill>
+                  </a:tcPr>
+                </a:tc>
+                <a:tc>
+                  <a:txBody>
+                    <a:bodyPr/>
+                    <a:lstStyle/>
+                    <a:p>
+                      <a:pPr algn="ctr"/>
+                      <a:r>
+                        <a:rPr sz="720">
+                          <a:solidFill>
+                            <a:srgbClr val="1E2226"/>
+                          </a:solidFill>
+                          <a:latin typeface="Aptos"/>
+                        </a:rPr>
+                        <a:t>17.5</a:t>
+                      </a:r>
+                    </a:p>
+                  </a:txBody>
+                  <a:tcPr marL="36576" marR="36576" marT="18288" marB="18288">
+                    <a:solidFill>
+                      <a:srgbClr val="EFF2F5"/>
+                    </a:solidFill>
+                  </a:tcPr>
+                </a:tc>
+                <a:tc>
+                  <a:txBody>
+                    <a:bodyPr/>
+                    <a:lstStyle/>
+                    <a:p>
+                      <a:pPr algn="ctr"/>
+                      <a:r>
+                        <a:rPr sz="720">
+                          <a:solidFill>
+                            <a:srgbClr val="1E2226"/>
+                          </a:solidFill>
+                          <a:latin typeface="Aptos"/>
+                        </a:rPr>
+                        <a:t>2.07x</a:t>
+                      </a:r>
+                    </a:p>
+                  </a:txBody>
+                  <a:tcPr marL="36576" marR="36576" marT="18288" marB="18288">
+                    <a:solidFill>
+                      <a:srgbClr val="EFF2F5"/>
+                    </a:solidFill>
+                  </a:tcPr>
+                </a:tc>
+                <a:tc>
+                  <a:txBody>
+                    <a:bodyPr/>
+                    <a:lstStyle/>
+                    <a:p>
+                      <a:pPr algn="ctr"/>
+                      <a:r>
+                        <a:rPr sz="720">
+                          <a:solidFill>
+                            <a:srgbClr val="1E2226"/>
+                          </a:solidFill>
+                          <a:latin typeface="Aptos"/>
+                        </a:rPr>
+                        <a:t>15.6%</a:t>
+                      </a:r>
+                    </a:p>
+                  </a:txBody>
+                  <a:tcPr marL="36576" marR="36576" marT="18288" marB="18288">
+                    <a:solidFill>
+                      <a:srgbClr val="EFF2F5"/>
+                    </a:solidFill>
+                  </a:tcPr>
+                </a:tc>
+              </a:tr>
+              <a:tr h="471830">
+                <a:tc>
+                  <a:txBody>
+                    <a:bodyPr/>
+                    <a:lstStyle/>
+                    <a:p>
+                      <a:pPr algn="l"/>
+                      <a:r>
+                        <a:rPr sz="720">
+                          <a:solidFill>
+                            <a:srgbClr val="1E2226"/>
+                          </a:solidFill>
+                          <a:latin typeface="Aptos"/>
+                        </a:rPr>
+                        <a:t>Cash retained</a:t>
+                      </a:r>
+                    </a:p>
+                  </a:txBody>
+                  <a:tcPr marL="36576" marR="36576" marT="18288" marB="18288">
+                    <a:solidFill>
+                      <a:srgbClr val="FFFFFF"/>
+                    </a:solidFill>
+                  </a:tcPr>
+                </a:tc>
+                <a:tc>
+                  <a:txBody>
+                    <a:bodyPr/>
+                    <a:lstStyle/>
+                    <a:p>
+                      <a:pPr algn="ctr"/>
+                      <a:r>
+                        <a:rPr sz="720">
+                          <a:solidFill>
+                            <a:srgbClr val="1E2226"/>
+                          </a:solidFill>
+                          <a:latin typeface="Aptos"/>
+                        </a:rPr>
+                        <a:t>11.9</a:t>
+                      </a:r>
+                    </a:p>
+                  </a:txBody>
+                  <a:tcPr marL="36576" marR="36576" marT="18288" marB="18288">
+                    <a:solidFill>
+                      <a:srgbClr val="FFFFFF"/>
+                    </a:solidFill>
+                  </a:tcPr>
+                </a:tc>
+                <a:tc>
+                  <a:txBody>
+                    <a:bodyPr/>
+                    <a:lstStyle/>
+                    <a:p>
+                      <a:pPr algn="ctr"/>
+                      <a:r>
+                        <a:rPr sz="720">
+                          <a:solidFill>
+                            <a:srgbClr val="1E2226"/>
+                          </a:solidFill>
+                          <a:latin typeface="Aptos"/>
+                        </a:rPr>
+                        <a:t>20.9</a:t>
+                      </a:r>
+                    </a:p>
+                  </a:txBody>
+                  <a:tcPr marL="36576" marR="36576" marT="18288" marB="18288">
+                    <a:solidFill>
+                      <a:srgbClr val="FFFFFF"/>
+                    </a:solidFill>
+                  </a:tcPr>
+                </a:tc>
+                <a:tc>
+                  <a:txBody>
+                    <a:bodyPr/>
+                    <a:lstStyle/>
+                    <a:p>
+                      <a:pPr algn="ctr"/>
+                      <a:r>
+                        <a:rPr sz="720">
+                          <a:solidFill>
+                            <a:srgbClr val="1E2226"/>
+                          </a:solidFill>
+                          <a:latin typeface="Aptos"/>
+                        </a:rPr>
+                        <a:t>1.76x</a:t>
+                      </a:r>
+                    </a:p>
+                  </a:txBody>
+                  <a:tcPr marL="36576" marR="36576" marT="18288" marB="18288">
+                    <a:solidFill>
+                      <a:srgbClr val="FFFFFF"/>
+                    </a:solidFill>
+                  </a:tcPr>
+                </a:tc>
+                <a:tc>
+                  <a:txBody>
+                    <a:bodyPr/>
+                    <a:lstStyle/>
+                    <a:p>
+                      <a:pPr algn="ctr"/>
+                      <a:r>
+                        <a:rPr sz="720">
+                          <a:solidFill>
+                            <a:srgbClr val="1E2226"/>
+                          </a:solidFill>
+                          <a:latin typeface="Aptos"/>
+                        </a:rPr>
+                        <a:t>12.0%</a:t>
+                      </a:r>
+                    </a:p>
+                  </a:txBody>
+                  <a:tcPr marL="36576" marR="36576" marT="18288" marB="18288">
+                    <a:solidFill>
+                      <a:srgbClr val="FFFFFF"/>
+                    </a:solidFill>
+                  </a:tcPr>
+                </a:tc>
+              </a:tr>
+              <a:tr h="471830">
+                <a:tc>
+                  <a:txBody>
+                    <a:bodyPr/>
+                    <a:lstStyle/>
+                    <a:p>
+                      <a:pPr algn="l"/>
+                      <a:r>
+                        <a:rPr sz="720">
+                          <a:solidFill>
+                            <a:srgbClr val="1E2226"/>
+                          </a:solidFill>
+                          <a:latin typeface="Aptos"/>
+                        </a:rPr>
+                        <a:t>Trapped cash</a:t>
+                      </a:r>
+                    </a:p>
+                  </a:txBody>
+                  <a:tcPr marL="36576" marR="36576" marT="18288" marB="18288">
+                    <a:solidFill>
+                      <a:srgbClr val="EFF2F5"/>
+                    </a:solidFill>
+                  </a:tcPr>
+                </a:tc>
+                <a:tc>
+                  <a:txBody>
+                    <a:bodyPr/>
+                    <a:lstStyle/>
+                    <a:p>
+                      <a:pPr algn="ctr"/>
+                      <a:r>
+                        <a:rPr sz="720">
+                          <a:solidFill>
+                            <a:srgbClr val="1E2226"/>
+                          </a:solidFill>
+                          <a:latin typeface="Aptos"/>
+                        </a:rPr>
+                        <a:t>11.9</a:t>
+                      </a:r>
+                    </a:p>
+                  </a:txBody>
+                  <a:tcPr marL="36576" marR="36576" marT="18288" marB="18288">
+                    <a:solidFill>
+                      <a:srgbClr val="EFF2F5"/>
+                    </a:solidFill>
+                  </a:tcPr>
+                </a:tc>
+                <a:tc>
+                  <a:txBody>
+                    <a:bodyPr/>
+                    <a:lstStyle/>
+                    <a:p>
+                      <a:pPr algn="ctr"/>
+                      <a:r>
+                        <a:rPr sz="720">
+                          <a:solidFill>
+                            <a:srgbClr val="1E2226"/>
+                          </a:solidFill>
+                          <a:latin typeface="Aptos"/>
+                        </a:rPr>
+                        <a:t>17.5</a:t>
+                      </a:r>
+                    </a:p>
+                  </a:txBody>
+                  <a:tcPr marL="36576" marR="36576" marT="18288" marB="18288">
+                    <a:solidFill>
+                      <a:srgbClr val="EFF2F5"/>
+                    </a:solidFill>
+                  </a:tcPr>
+                </a:tc>
+                <a:tc>
+                  <a:txBody>
+                    <a:bodyPr/>
+                    <a:lstStyle/>
+                    <a:p>
+                      <a:pPr algn="ctr"/>
+                      <a:r>
+                        <a:rPr sz="720">
+                          <a:solidFill>
+                            <a:srgbClr val="1E2226"/>
+                          </a:solidFill>
+                          <a:latin typeface="Aptos"/>
+                        </a:rPr>
+                        <a:t>1.47x</a:t>
+                      </a:r>
+                    </a:p>
+                  </a:txBody>
+                  <a:tcPr marL="36576" marR="36576" marT="18288" marB="18288">
+                    <a:solidFill>
+                      <a:srgbClr val="EFF2F5"/>
+                    </a:solidFill>
+                  </a:tcPr>
+                </a:tc>
+                <a:tc>
+                  <a:txBody>
+                    <a:bodyPr/>
+                    <a:lstStyle/>
+                    <a:p>
+                      <a:pPr algn="ctr"/>
+                      <a:r>
+                        <a:rPr sz="720">
+                          <a:solidFill>
+                            <a:srgbClr val="1E2226"/>
+                          </a:solidFill>
+                          <a:latin typeface="Aptos"/>
+                        </a:rPr>
+                        <a:t>8.1%</a:t>
+                      </a:r>
+                    </a:p>
+                  </a:txBody>
+                  <a:tcPr marL="36576" marR="36576" marT="18288" marB="18288">
+                    <a:solidFill>
+                      <a:srgbClr val="EFF2F5"/>
+                    </a:solidFill>
+                  </a:tcPr>
+                </a:tc>
+              </a:tr>
+            </a:tbl>
+          </a:graphicData>
+        </a:graphic>
+      </p:graphicFrame>
+      <p:sp>
+        <p:nvSpPr>
+          <p:cNvPr id="25" name="TextBox 24"/>
+          <p:cNvSpPr txBox="1"/>
+          <p:nvPr/>
+        </p:nvSpPr>
+        <p:spPr>
+          <a:xfrm>
+            <a:off x="6236208" y="4160520"/>
+            <a:ext cx="5074920" cy="585216"/>
+          </a:xfrm>
+          <a:prstGeom prst="rect">
+            <a:avLst/>
+          </a:prstGeom>
+          <a:noFill/>
+        </p:spPr>
+        <p:txBody>
+          <a:bodyPr wrap="square" lIns="73152" rIns="73152" tIns="36576" bIns="36576" anchor="t">
+            <a:spAutoFit/>
+          </a:bodyPr>
+          <a:lstStyle/>
+          <a:p>
+            <a:pPr algn="l"/>
+            <a:r>
+              <a:rPr sz="750" b="0">
+                <a:solidFill>
+                  <a:srgbClr val="5F6970"/>
+                </a:solidFill>
+                <a:latin typeface="Aptos"/>
+              </a:rPr>
+              <a:t>Extraction needs distributable reserves, lender consent, clean accounts &amp; time — none assured pre-DD.</a:t>
+            </a:r>
+          </a:p>
+        </p:txBody>
+      </p:sp>
+      <p:sp>
+        <p:nvSpPr>
+          <p:cNvPr id="26" name="Rectangle 25"/>
+          <p:cNvSpPr/>
+          <p:nvPr/>
+        </p:nvSpPr>
+        <p:spPr>
+          <a:xfrm>
+            <a:off x="502920" y="5321808"/>
+            <a:ext cx="10927080" cy="658368"/>
+          </a:xfrm>
+          <a:prstGeom prst="rect">
+            <a:avLst/>
+          </a:prstGeom>
+          <a:solidFill>
+            <a:srgbClr val="F1F7F6"/>
+          </a:solidFill>
+          <a:ln>
+            <a:solidFill>
+              <a:srgbClr val="B4D7D2"/>
+            </a:solidFill>
+          </a:ln>
+        </p:spPr>
+        <p:style>
+          <a:lnRef idx="1">
+            <a:schemeClr val="accent1"/>
+          </a:lnRef>
+          <a:fillRef idx="3">
+            <a:schemeClr val="accent1"/>
+          </a:fillRef>
+          <a:effectRef idx="2">
+            <a:schemeClr val="accent1"/>
+          </a:effectRef>
+          <a:fontRef idx="minor">
+            <a:schemeClr val="lt1"/>
+          </a:fontRef>
+        </p:style>
+        <p:txBody>
+          <a:bodyPr rtlCol="0" anchor="ctr"/>
+          <a:lstStyle/>
+          <a:p>
+            <a:pPr algn="ctr"/>
+          </a:p>
+        </p:txBody>
+      </p:sp>
+      <p:sp>
+        <p:nvSpPr>
+          <p:cNvPr id="27" name="TextBox 26"/>
+          <p:cNvSpPr txBox="1"/>
+          <p:nvPr/>
+        </p:nvSpPr>
+        <p:spPr>
+          <a:xfrm>
+            <a:off x="685800" y="5468112"/>
+            <a:ext cx="10561320" cy="320040"/>
+          </a:xfrm>
+          <a:prstGeom prst="rect">
+            <a:avLst/>
+          </a:prstGeom>
+          <a:noFill/>
+        </p:spPr>
+        <p:txBody>
+          <a:bodyPr wrap="none" lIns="73152" rIns="73152" tIns="36576" bIns="36576" anchor="t">
+            <a:spAutoFit/>
+          </a:bodyPr>
+          <a:lstStyle/>
+          <a:p>
+            <a:pPr algn="ctr"/>
+            <a:r>
+              <a:rPr sz="860" b="1">
+                <a:solidFill>
+                  <a:srgbClr val="1E2226"/>
+                </a:solidFill>
+                <a:latin typeface="Aptos"/>
+              </a:rPr>
+              <a:t>Takeaway: AISAN screens cheaply partly on excess cash, but returns hinge on whether that cash is legally and practically extractable. Treat as a confirmatory DD item, not a base-case assumption.</a:t>
+            </a:r>
+          </a:p>
+        </p:txBody>
+      </p:sp>
+      <p:sp>
+        <p:nvSpPr>
+          <p:cNvPr id="28" name="TextBox 27"/>
+          <p:cNvSpPr txBox="1"/>
+          <p:nvPr/>
+        </p:nvSpPr>
+        <p:spPr>
+          <a:xfrm>
+            <a:off x="502920" y="6053328"/>
+            <a:ext cx="10927080" cy="228600"/>
+          </a:xfrm>
+          <a:prstGeom prst="rect">
+            <a:avLst/>
+          </a:prstGeom>
+          <a:noFill/>
+        </p:spPr>
+        <p:txBody>
+          <a:bodyPr wrap="square" lIns="73152" rIns="73152" tIns="36576" bIns="36576" anchor="t">
+            <a:spAutoFit/>
+          </a:bodyPr>
+          <a:lstStyle/>
+          <a:p>
+            <a:pPr algn="l"/>
+            <a:r>
+              <a:rPr sz="700" b="0">
+                <a:solidFill>
+                  <a:srgbClr val="5F6970"/>
+                </a:solidFill>
+                <a:latin typeface="Aptos"/>
+              </a:rPr>
+              <a:t>Source: accompanying Excel model (Returns — cash availability &amp; MIP sensitivity). Illustrative; ¥bn, 5-yr hold.</a:t>
+            </a:r>
+          </a:p>
+        </p:txBody>
+      </p:sp>
+      <p:sp>
+        <p:nvSpPr>
+          <p:cNvPr id="29" name="TextBox 28"/>
+          <p:cNvSpPr txBox="1"/>
+          <p:nvPr/>
+        </p:nvSpPr>
+        <p:spPr>
+          <a:xfrm>
+            <a:off x="320040" y="6473952"/>
+            <a:ext cx="4572000" cy="201168"/>
+          </a:xfrm>
+          <a:prstGeom prst="rect">
+            <a:avLst/>
+          </a:prstGeom>
+          <a:noFill/>
+        </p:spPr>
+        <p:txBody>
+          <a:bodyPr wrap="none" lIns="73152" rIns="73152" tIns="36576" bIns="36576" anchor="t">
+            <a:spAutoFit/>
+          </a:bodyPr>
+          <a:lstStyle/>
+          <a:p>
+            <a:pPr algn="l"/>
+            <a:r>
+              <a:rPr sz="750" b="0">
+                <a:solidFill>
+                  <a:srgbClr val="5F6970"/>
+                </a:solidFill>
+                <a:latin typeface="Aptos"/>
+              </a:rPr>
+              <a:t>Project Measure  ·  Strictly Private &amp; Confidential</a:t>
+            </a:r>
+          </a:p>
+        </p:txBody>
+      </p:sp>
+      <p:sp>
+        <p:nvSpPr>
+          <p:cNvPr id="30" name="TextBox 29"/>
+          <p:cNvSpPr txBox="1"/>
+          <p:nvPr/>
+        </p:nvSpPr>
+        <p:spPr>
+          <a:xfrm>
+            <a:off x="11384280" y="6473952"/>
+            <a:ext cx="411480" cy="201168"/>
+          </a:xfrm>
+          <a:prstGeom prst="rect">
+            <a:avLst/>
+          </a:prstGeom>
+          <a:noFill/>
+        </p:spPr>
+        <p:txBody>
+          <a:bodyPr wrap="none" lIns="73152" rIns="73152" tIns="36576" bIns="36576" anchor="t">
+            <a:spAutoFit/>
+          </a:bodyPr>
+          <a:lstStyle/>
+          <a:p>
+            <a:pPr algn="r"/>
+            <a:r>
+              <a:rPr sz="750" b="0">
+                <a:solidFill>
+                  <a:srgbClr val="5F6970"/>
+                </a:solidFill>
+                <a:latin typeface="Aptos"/>
+              </a:rPr>
+              <a:t>15</a:t>
+            </a:r>
+          </a:p>
+        </p:txBody>
+      </p:sp>
+    </p:spTree>
+  </p:cSld>
+  <p:clrMapOvr>
+    <a:masterClrMapping/>
+  </p:clrMapOvr>
+</p:sld>
+</file>
+
+<file path=ppt/slides/slide16.xml><?xml version="1.0" encoding="utf-8"?>
 <ns0:sld xmlns:a="http://schemas.openxmlformats.org/drawingml/2006/main" xmlns:ns0="http://schemas.openxmlformats.org/presentationml/2006/main" xmlns:ns2="http://schemas.openxmlformats.org/officeDocument/2006/relationships">
   <ns0:cSld name="Slide 13">
     <ns0:bg>
@@ -14859,7 +16659,7 @@
                 <a:ea typeface="Georgia" pitchFamily="34" charset="-122"/>
                 <a:cs typeface="Georgia" pitchFamily="34" charset="-120"/>
               </a:rPr>
-              <a:t>14</a:t>
+              <a:t>15</a:t>
             </a:r>
             <a:endParaRPr lang="en-US" sz="1500" dirty="0"/>
           </a:p>
@@ -15971,7 +17771,7 @@
                 <a:ea typeface="Calibri" pitchFamily="34" charset="-122"/>
                 <a:cs typeface="Calibri" pitchFamily="34" charset="-120"/>
               </a:rPr>
-              <a:t>15</a:t>
+              <a:t>16</a:t>
             </a:r>
             <a:endParaRPr lang="en-US" sz="850" dirty="0"/>
           </a:p>
@@ -15985,7 +17785,7 @@
 </ns0:sld>
 </file>
 
-<file path=ppt/slides/slide16.xml><?xml version="1.0" encoding="utf-8"?>
+<file path=ppt/slides/slide17.xml><?xml version="1.0" encoding="utf-8"?>
 <p:sld xmlns:a="http://schemas.openxmlformats.org/drawingml/2006/main" xmlns:r="http://schemas.openxmlformats.org/officeDocument/2006/relationships" xmlns:p="http://schemas.openxmlformats.org/presentationml/2006/main">
   <p:cSld name="Slide 14">
     <p:bg>
@@ -16042,7 +17842,7 @@
                 <a:ea typeface="Georgia" pitchFamily="34" charset="-122"/>
                 <a:cs typeface="Georgia" pitchFamily="34" charset="-120"/>
               </a:rPr>
-              <a:t>15</a:t>
+              <a:t>16</a:t>
             </a:r>
             <a:endParaRPr lang="en-US" sz="1500" dirty="0"/>
           </a:p>
@@ -17615,7 +19415,7 @@
                 <a:ea typeface="Calibri" pitchFamily="34" charset="-122"/>
                 <a:cs typeface="Calibri" pitchFamily="34" charset="-120"/>
               </a:rPr>
-              <a:t>16</a:t>
+              <a:t>17</a:t>
             </a:r>
             <a:endParaRPr lang="en-US" sz="850" dirty="0"/>
           </a:p>
@@ -17629,7 +19429,7 @@
 </p:sld>
 </file>
 
-<file path=ppt/slides/slide17.xml><?xml version="1.0" encoding="utf-8"?>
+<file path=ppt/slides/slide18.xml><?xml version="1.0" encoding="utf-8"?>
 <ns0:sld xmlns:a="http://schemas.openxmlformats.org/drawingml/2006/main" xmlns:ns0="http://schemas.openxmlformats.org/presentationml/2006/main" xmlns:ns2="http://schemas.openxmlformats.org/officeDocument/2006/relationships">
   <ns0:cSld name="Slide 15">
     <ns0:bg>
@@ -17686,7 +19486,7 @@
                 <a:ea typeface="Georgia" pitchFamily="34" charset="-122"/>
                 <a:cs typeface="Georgia" pitchFamily="34" charset="-120"/>
               </a:rPr>
-              <a:t>16</a:t>
+              <a:t>17</a:t>
             </a:r>
             <a:endParaRPr lang="en-US" sz="1500" dirty="0"/>
           </a:p>
@@ -19352,7 +21152,7 @@
                 <a:ea typeface="Calibri" pitchFamily="34" charset="-122"/>
                 <a:cs typeface="Calibri" pitchFamily="34" charset="-120"/>
               </a:rPr>
-              <a:t>17</a:t>
+              <a:t>18</a:t>
             </a:r>
             <a:endParaRPr lang="en-US" sz="850" dirty="0"/>
           </a:p>
@@ -19366,7 +21166,7 @@
 </ns0:sld>
 </file>
 
-<file path=ppt/slides/slide18.xml><?xml version="1.0" encoding="utf-8"?>
+<file path=ppt/slides/slide19.xml><?xml version="1.0" encoding="utf-8"?>
 <ns0:sld xmlns:a="http://schemas.openxmlformats.org/drawingml/2006/main" xmlns:ns0="http://schemas.openxmlformats.org/presentationml/2006/main">
   <ns0:cSld name="Slide 16">
     <ns0:bg>
@@ -20172,7 +21972,7 @@
                 <a:ea typeface="Calibri" pitchFamily="34" charset="-122"/>
                 <a:cs typeface="Calibri" pitchFamily="34" charset="-120"/>
               </a:rPr>
-              <a:t>Revisit only if returns clear the hurdle post-clearance; walk-to-price is ~¥2,031/share at a 20% hurdle absent value-up beyond base</a:t>
+              <a:t>Keep on watchlist; bid only after the probe clears, financials are re-underwritten, excess-cash availability is verified, and walk-to-price (~¥2,031/share) supports a clean 20%+ gross IRR</a:t>
             </a:r>
             <a:endParaRPr lang="en-US" sz="1050" dirty="0"/>
           </a:p>
@@ -20283,1260 +22083,6 @@
               <a:t>Project Measure  ·  June 2026</a:t>
             </a:r>
             <a:endParaRPr lang="en-US" sz="900" dirty="0"/>
-          </a:p>
-        </ns0:txBody>
-      </ns0:sp>
-    </ns0:spTree>
-  </ns0:cSld>
-  <ns0:clrMapOvr>
-    <a:masterClrMapping/>
-  </ns0:clrMapOvr>
-</ns0:sld>
-</file>
-
-<file path=ppt/slides/slide19.xml><?xml version="1.0" encoding="utf-8"?>
-<ns0:sld xmlns:a="http://schemas.openxmlformats.org/drawingml/2006/main" xmlns:ns0="http://schemas.openxmlformats.org/presentationml/2006/main">
-  <ns0:cSld name="Slide 17">
-    <ns0:bg>
-      <ns0:bgPr>
-        <a:solidFill>
-          <a:srgbClr val="FFFFFF"/>
-        </a:solidFill>
-      </ns0:bgPr>
-    </ns0:bg>
-    <ns0:spTree>
-      <ns0:nvGrpSpPr>
-        <ns0:cNvPr id="1" name=""/>
-        <ns0:cNvGrpSpPr/>
-        <ns0:nvPr/>
-      </ns0:nvGrpSpPr>
-      <ns0:grpSpPr>
-        <a:xfrm>
-          <a:off x="0" y="0"/>
-          <a:ext cx="0" cy="0"/>
-          <a:chOff x="0" y="0"/>
-          <a:chExt cx="0" cy="0"/>
-        </a:xfrm>
-      </ns0:grpSpPr>
-      <ns0:sp>
-        <ns0:nvSpPr>
-          <ns0:cNvPr id="2" name="Text 0"/>
-          <ns0:cNvSpPr/>
-          <ns0:nvPr/>
-        </ns0:nvSpPr>
-        <ns0:spPr>
-          <a:xfrm>
-            <a:off x="548640" y="420624"/>
-            <a:ext cx="566928" cy="457200"/>
-          </a:xfrm>
-          <a:prstGeom prst="rect">
-            <a:avLst/>
-          </a:prstGeom>
-          <a:noFill/>
-          <a:ln/>
-        </ns0:spPr>
-        <ns0:txBody>
-          <a:bodyPr wrap="square" lIns="0" tIns="0" rIns="0" bIns="0" rtlCol="0" anchor="t"/>
-          <a:lstStyle/>
-          <a:p>
-            <a:r>
-              <a:rPr sz="1500" b="1">
-                <a:solidFill>
-                  <a:srgbClr val="C8A951"/>
-                </a:solidFill>
-                <a:latin typeface="Georgia"/>
-              </a:rPr>
-              <a:t>A</a:t>
-            </a:r>
-          </a:p>
-        </ns0:txBody>
-      </ns0:sp>
-      <ns0:sp>
-        <ns0:nvSpPr>
-          <ns0:cNvPr id="3" name="Text 1"/>
-          <ns0:cNvSpPr/>
-          <ns0:nvPr/>
-        </ns0:nvSpPr>
-        <ns0:spPr>
-          <a:xfrm>
-            <a:off x="1078992" y="365760"/>
-            <a:ext cx="8778240" cy="566928"/>
-          </a:xfrm>
-          <a:prstGeom prst="rect">
-            <a:avLst/>
-          </a:prstGeom>
-          <a:noFill/>
-          <a:ln/>
-        </ns0:spPr>
-        <ns0:txBody>
-          <a:bodyPr wrap="square" lIns="0" tIns="0" rIns="0" bIns="0" rtlCol="0" anchor="t"/>
-          <a:lstStyle/>
-          <a:p>
-            <a:pPr algn="l" indent="0" marL="0">
-              <a:buNone/>
-            </a:pPr>
-            <a:r>
-              <a:rPr lang="en-US" sz="2700" b="1" dirty="0">
-                <a:solidFill>
-                  <a:srgbClr val="1E2761"/>
-                </a:solidFill>
-                <a:latin typeface="Georgia" pitchFamily="34" charset="0"/>
-                <a:ea typeface="Georgia" pitchFamily="34" charset="-122"/>
-                <a:cs typeface="Georgia" pitchFamily="34" charset="-120"/>
-              </a:rPr>
-              <a:t>Source Appendix</a:t>
-            </a:r>
-            <a:endParaRPr lang="en-US" sz="2700" dirty="0"/>
-          </a:p>
-        </ns0:txBody>
-      </ns0:sp>
-      <ns0:sp>
-        <ns0:nvSpPr>
-          <ns0:cNvPr id="4" name="Text 2"/>
-          <ns0:cNvSpPr/>
-          <ns0:nvPr/>
-        </ns0:nvSpPr>
-        <ns0:spPr>
-          <a:xfrm>
-            <a:off x="1097280" y="914400"/>
-            <a:ext cx="10424160" cy="310896"/>
-          </a:xfrm>
-          <a:prstGeom prst="rect">
-            <a:avLst/>
-          </a:prstGeom>
-          <a:noFill/>
-          <a:ln/>
-        </ns0:spPr>
-        <ns0:txBody>
-          <a:bodyPr wrap="square" lIns="0" tIns="0" rIns="0" bIns="0" rtlCol="0" anchor="t"/>
-          <a:lstStyle/>
-          <a:p>
-            <a:pPr algn="l" indent="0" marL="0">
-              <a:buNone/>
-            </a:pPr>
-            <a:r>
-              <a:rPr lang="en-US" sz="1250" i="1" dirty="0">
-                <a:solidFill>
-                  <a:srgbClr val="5B6485"/>
-                </a:solidFill>
-                <a:latin typeface="Calibri" pitchFamily="34" charset="0"/>
-                <a:ea typeface="Calibri" pitchFamily="34" charset="-122"/>
-                <a:cs typeface="Calibri" pitchFamily="34" charset="-120"/>
-              </a:rPr>
-              <a:t>Selected public sources — every factual claim is to be verified in confirmatory diligence</a:t>
-            </a:r>
-            <a:endParaRPr lang="en-US" sz="1250" dirty="0"/>
-          </a:p>
-        </ns0:txBody>
-      </ns0:sp>
-      <ns0:sp>
-        <ns0:nvSpPr>
-          <ns0:cNvPr id="5" name="Text 3"/>
-          <ns0:cNvSpPr/>
-          <ns0:nvPr/>
-        </ns0:nvSpPr>
-        <ns0:spPr>
-          <a:xfrm>
-            <a:off x="548640" y="1371600"/>
-            <a:ext cx="365760" cy="237744"/>
-          </a:xfrm>
-          <a:prstGeom prst="rect">
-            <a:avLst/>
-          </a:prstGeom>
-          <a:noFill/>
-          <a:ln/>
-        </ns0:spPr>
-        <ns0:txBody>
-          <a:bodyPr wrap="square" lIns="0" tIns="0" rIns="0" bIns="0" rtlCol="0" anchor="t"/>
-          <a:lstStyle/>
-          <a:p>
-            <a:pPr indent="0" marL="0">
-              <a:buNone/>
-            </a:pPr>
-            <a:r>
-              <a:rPr lang="en-US" sz="1100" b="1" dirty="0">
-                <a:solidFill>
-                  <a:srgbClr val="C8A951"/>
-                </a:solidFill>
-                <a:latin typeface="Georgia" pitchFamily="34" charset="0"/>
-                <a:ea typeface="Georgia" pitchFamily="34" charset="-122"/>
-                <a:cs typeface="Georgia" pitchFamily="34" charset="-120"/>
-              </a:rPr>
-              <a:t>1</a:t>
-            </a:r>
-            <a:endParaRPr lang="en-US" sz="1100" dirty="0"/>
-          </a:p>
-        </ns0:txBody>
-      </ns0:sp>
-      <ns0:sp>
-        <ns0:nvSpPr>
-          <ns0:cNvPr id="6" name="Text 4"/>
-          <ns0:cNvSpPr/>
-          <ns0:nvPr/>
-        </ns0:nvSpPr>
-        <ns0:spPr>
-          <a:xfrm>
-            <a:off x="932688" y="1371600"/>
-            <a:ext cx="10698480" cy="274320"/>
-          </a:xfrm>
-          <a:prstGeom prst="rect">
-            <a:avLst/>
-          </a:prstGeom>
-          <a:noFill/>
-          <a:ln/>
-        </ns0:spPr>
-        <ns0:txBody>
-          <a:bodyPr wrap="square" lIns="0" tIns="0" rIns="0" bIns="0" rtlCol="0" anchor="t"/>
-          <a:lstStyle/>
-          <a:p>
-            <a:pPr indent="0" marL="0">
-              <a:lnSpc>
-                <a:spcPct val="95000"/>
-              </a:lnSpc>
-              <a:buNone/>
-            </a:pPr>
-            <a:r>
-              <a:rPr lang="en-US" sz="970" b="1" dirty="0">
-                <a:solidFill>
-                  <a:srgbClr val="1E2761"/>
-                </a:solidFill>
-                <a:latin typeface="Calibri" pitchFamily="34" charset="0"/>
-                <a:ea typeface="Calibri" pitchFamily="34" charset="-122"/>
-                <a:cs typeface="Calibri" pitchFamily="34" charset="-120"/>
-              </a:rPr>
-              <a:t>AISAN IR — Special Investigation Committee notice (3 Apr 2026)</a:t>
-            </a:r>
-            <a:pPr indent="0" marL="0">
-              <a:lnSpc>
-                <a:spcPct val="95000"/>
-              </a:lnSpc>
-              <a:buNone/>
-            </a:pPr>
-            <a:r>
-              <a:rPr lang="en-US" sz="970" dirty="0">
-                <a:solidFill>
-                  <a:srgbClr val="3A4059"/>
-                </a:solidFill>
-                <a:latin typeface="Calibri" pitchFamily="34" charset="0"/>
-                <a:ea typeface="Calibri" pitchFamily="34" charset="-122"/>
-                <a:cs typeface="Calibri" pitchFamily="34" charset="-120"/>
-              </a:rPr>
-              <a:t>  —  subsidiary fraud probe: scope, trigger, committee composition</a:t>
-            </a:r>
-            <a:endParaRPr lang="en-US" sz="970" dirty="0"/>
-          </a:p>
-        </ns0:txBody>
-      </ns0:sp>
-      <ns0:sp>
-        <ns0:nvSpPr>
-          <ns0:cNvPr id="7" name="Text 5"/>
-          <ns0:cNvSpPr/>
-          <ns0:nvPr/>
-        </ns0:nvSpPr>
-        <ns0:spPr>
-          <a:xfrm>
-            <a:off x="932688" y="1618488"/>
-            <a:ext cx="10698480" cy="201168"/>
-          </a:xfrm>
-          <a:prstGeom prst="rect">
-            <a:avLst/>
-          </a:prstGeom>
-          <a:noFill/>
-          <a:ln/>
-        </ns0:spPr>
-        <ns0:txBody>
-          <a:bodyPr wrap="square" lIns="0" tIns="0" rIns="0" bIns="0" rtlCol="0" anchor="t"/>
-          <a:lstStyle/>
-          <a:p>
-            <a:pPr indent="0" marL="0">
-              <a:buNone/>
-            </a:pPr>
-            <a:r>
-              <a:rPr lang="en-US" sz="800" i="1" dirty="0">
-                <a:solidFill>
-                  <a:srgbClr val="5B6485"/>
-                </a:solidFill>
-                <a:latin typeface="Calibri" pitchFamily="34" charset="0"/>
-                <a:ea typeface="Calibri" pitchFamily="34" charset="-122"/>
-                <a:cs typeface="Calibri" pitchFamily="34" charset="-120"/>
-              </a:rPr>
-              <a:t>https://www.aisantec.co.jp/information/4167/   ·   retrieved 7 Jun 2026</a:t>
-            </a:r>
-            <a:endParaRPr lang="en-US" sz="800" dirty="0"/>
-          </a:p>
-        </ns0:txBody>
-      </ns0:sp>
-      <ns0:sp>
-        <ns0:nvSpPr>
-          <ns0:cNvPr id="8" name="Text 6"/>
-          <ns0:cNvSpPr/>
-          <ns0:nvPr/>
-        </ns0:nvSpPr>
-        <ns0:spPr>
-          <a:xfrm>
-            <a:off x="548640" y="1920240"/>
-            <a:ext cx="365760" cy="237744"/>
-          </a:xfrm>
-          <a:prstGeom prst="rect">
-            <a:avLst/>
-          </a:prstGeom>
-          <a:noFill/>
-          <a:ln/>
-        </ns0:spPr>
-        <ns0:txBody>
-          <a:bodyPr wrap="square" lIns="0" tIns="0" rIns="0" bIns="0" rtlCol="0" anchor="t"/>
-          <a:lstStyle/>
-          <a:p>
-            <a:pPr indent="0" marL="0">
-              <a:buNone/>
-            </a:pPr>
-            <a:r>
-              <a:rPr lang="en-US" sz="1100" b="1" dirty="0">
-                <a:solidFill>
-                  <a:srgbClr val="C8A951"/>
-                </a:solidFill>
-                <a:latin typeface="Georgia" pitchFamily="34" charset="0"/>
-                <a:ea typeface="Georgia" pitchFamily="34" charset="-122"/>
-                <a:cs typeface="Georgia" pitchFamily="34" charset="-120"/>
-              </a:rPr>
-              <a:t>2</a:t>
-            </a:r>
-            <a:endParaRPr lang="en-US" sz="1100" dirty="0"/>
-          </a:p>
-        </ns0:txBody>
-      </ns0:sp>
-      <ns0:sp>
-        <ns0:nvSpPr>
-          <ns0:cNvPr id="9" name="Text 7"/>
-          <ns0:cNvSpPr/>
-          <ns0:nvPr/>
-        </ns0:nvSpPr>
-        <ns0:spPr>
-          <a:xfrm>
-            <a:off x="932688" y="1920240"/>
-            <a:ext cx="10698480" cy="274320"/>
-          </a:xfrm>
-          <a:prstGeom prst="rect">
-            <a:avLst/>
-          </a:prstGeom>
-          <a:noFill/>
-          <a:ln/>
-        </ns0:spPr>
-        <ns0:txBody>
-          <a:bodyPr wrap="square" lIns="0" tIns="0" rIns="0" bIns="0" rtlCol="0" anchor="t"/>
-          <a:lstStyle/>
-          <a:p>
-            <a:pPr indent="0" marL="0">
-              <a:lnSpc>
-                <a:spcPct val="95000"/>
-              </a:lnSpc>
-              <a:buNone/>
-            </a:pPr>
-            <a:r>
-              <a:rPr lang="en-US" sz="970" b="1" dirty="0">
-                <a:solidFill>
-                  <a:srgbClr val="1E2761"/>
-                </a:solidFill>
-                <a:latin typeface="Calibri" pitchFamily="34" charset="0"/>
-                <a:ea typeface="Calibri" pitchFamily="34" charset="-122"/>
-                <a:cs typeface="Calibri" pitchFamily="34" charset="-120"/>
-              </a:rPr>
-              <a:t>AISAN IR — share status / major shareholders</a:t>
-            </a:r>
-            <a:pPr indent="0" marL="0">
-              <a:lnSpc>
-                <a:spcPct val="95000"/>
-              </a:lnSpc>
-              <a:buNone/>
-            </a:pPr>
-            <a:r>
-              <a:rPr lang="en-US" sz="970" dirty="0">
-                <a:solidFill>
-                  <a:srgbClr val="3A4059"/>
-                </a:solidFill>
-                <a:latin typeface="Calibri" pitchFamily="34" charset="0"/>
-                <a:ea typeface="Calibri" pitchFamily="34" charset="-122"/>
-                <a:cs typeface="Calibri" pitchFamily="34" charset="-120"/>
-              </a:rPr>
-              <a:t>  —  issued shares 5,548,979; treasury shares 268,816; top holders</a:t>
-            </a:r>
-            <a:endParaRPr lang="en-US" sz="970" dirty="0"/>
-          </a:p>
-        </ns0:txBody>
-      </ns0:sp>
-      <ns0:sp>
-        <ns0:nvSpPr>
-          <ns0:cNvPr id="10" name="Text 8"/>
-          <ns0:cNvSpPr/>
-          <ns0:nvPr/>
-        </ns0:nvSpPr>
-        <ns0:spPr>
-          <a:xfrm>
-            <a:off x="932688" y="2167128"/>
-            <a:ext cx="10698480" cy="201168"/>
-          </a:xfrm>
-          <a:prstGeom prst="rect">
-            <a:avLst/>
-          </a:prstGeom>
-          <a:noFill/>
-          <a:ln/>
-        </ns0:spPr>
-        <ns0:txBody>
-          <a:bodyPr wrap="square" lIns="0" tIns="0" rIns="0" bIns="0" rtlCol="0" anchor="t"/>
-          <a:lstStyle/>
-          <a:p>
-            <a:pPr indent="0" marL="0">
-              <a:buNone/>
-            </a:pPr>
-            <a:r>
-              <a:rPr lang="en-US" sz="800" i="1" dirty="0">
-                <a:solidFill>
-                  <a:srgbClr val="5B6485"/>
-                </a:solidFill>
-                <a:latin typeface="Calibri" pitchFamily="34" charset="0"/>
-                <a:ea typeface="Calibri" pitchFamily="34" charset="-122"/>
-                <a:cs typeface="Calibri" pitchFamily="34" charset="-120"/>
-              </a:rPr>
-              <a:t>https://www.aisantec.co.jp/ir/stock/status/   ·   retrieved 7 Jun 2026</a:t>
-            </a:r>
-            <a:endParaRPr lang="en-US" sz="800" dirty="0"/>
-          </a:p>
-        </ns0:txBody>
-      </ns0:sp>
-      <ns0:sp>
-        <ns0:nvSpPr>
-          <ns0:cNvPr id="11" name="Text 9"/>
-          <ns0:cNvSpPr/>
-          <ns0:nvPr/>
-        </ns0:nvSpPr>
-        <ns0:spPr>
-          <a:xfrm>
-            <a:off x="548640" y="2468880"/>
-            <a:ext cx="365760" cy="237744"/>
-          </a:xfrm>
-          <a:prstGeom prst="rect">
-            <a:avLst/>
-          </a:prstGeom>
-          <a:noFill/>
-          <a:ln/>
-        </ns0:spPr>
-        <ns0:txBody>
-          <a:bodyPr wrap="square" lIns="0" tIns="0" rIns="0" bIns="0" rtlCol="0" anchor="t"/>
-          <a:lstStyle/>
-          <a:p>
-            <a:pPr indent="0" marL="0">
-              <a:buNone/>
-            </a:pPr>
-            <a:r>
-              <a:rPr lang="en-US" sz="1100" b="1" dirty="0">
-                <a:solidFill>
-                  <a:srgbClr val="C8A951"/>
-                </a:solidFill>
-                <a:latin typeface="Georgia" pitchFamily="34" charset="0"/>
-                <a:ea typeface="Georgia" pitchFamily="34" charset="-122"/>
-                <a:cs typeface="Georgia" pitchFamily="34" charset="-120"/>
-              </a:rPr>
-              <a:t>3</a:t>
-            </a:r>
-            <a:endParaRPr lang="en-US" sz="1100" dirty="0"/>
-          </a:p>
-        </ns0:txBody>
-      </ns0:sp>
-      <ns0:sp>
-        <ns0:nvSpPr>
-          <ns0:cNvPr id="12" name="Text 10"/>
-          <ns0:cNvSpPr/>
-          <ns0:nvPr/>
-        </ns0:nvSpPr>
-        <ns0:spPr>
-          <a:xfrm>
-            <a:off x="932688" y="2468880"/>
-            <a:ext cx="10698480" cy="274320"/>
-          </a:xfrm>
-          <a:prstGeom prst="rect">
-            <a:avLst/>
-          </a:prstGeom>
-          <a:noFill/>
-          <a:ln/>
-        </ns0:spPr>
-        <ns0:txBody>
-          <a:bodyPr wrap="square" lIns="0" tIns="0" rIns="0" bIns="0" rtlCol="0" anchor="t"/>
-          <a:lstStyle/>
-          <a:p>
-            <a:pPr indent="0" marL="0">
-              <a:lnSpc>
-                <a:spcPct val="95000"/>
-              </a:lnSpc>
-              <a:buNone/>
-            </a:pPr>
-            <a:r>
-              <a:rPr lang="en-US" sz="970" b="1" dirty="0">
-                <a:solidFill>
-                  <a:srgbClr val="1E2761"/>
-                </a:solidFill>
-                <a:latin typeface="Calibri" pitchFamily="34" charset="0"/>
-                <a:ea typeface="Calibri" pitchFamily="34" charset="-122"/>
-                <a:cs typeface="Calibri" pitchFamily="34" charset="-120"/>
-              </a:rPr>
-              <a:t>AISAN IR — FY2025 results &amp; FY2026 guidance (決算短信; results normally announced May)</a:t>
-            </a:r>
-            <a:pPr indent="0" marL="0">
-              <a:lnSpc>
-                <a:spcPct val="95000"/>
-              </a:lnSpc>
-              <a:buNone/>
-            </a:pPr>
-            <a:r>
-              <a:rPr lang="en-US" sz="970" dirty="0">
-                <a:solidFill>
-                  <a:srgbClr val="3A4059"/>
-                </a:solidFill>
-                <a:latin typeface="Calibri" pitchFamily="34" charset="0"/>
-                <a:ea typeface="Calibri" pitchFamily="34" charset="-122"/>
-                <a:cs typeface="Calibri" pitchFamily="34" charset="-120"/>
-              </a:rPr>
-              <a:t>  —  FY25A rev ¥6.22bn / OP ¥0.44bn; FY26E guidance ¥7.2bn / ¥0.6bn; FY26 results delayed (30-Apr-26 notice)</a:t>
-            </a:r>
-            <a:endParaRPr lang="en-US" sz="970" dirty="0"/>
-          </a:p>
-        </ns0:txBody>
-      </ns0:sp>
-      <ns0:sp>
-        <ns0:nvSpPr>
-          <ns0:cNvPr id="13" name="Text 11"/>
-          <ns0:cNvSpPr/>
-          <ns0:nvPr/>
-        </ns0:nvSpPr>
-        <ns0:spPr>
-          <a:xfrm>
-            <a:off x="932688" y="2715768"/>
-            <a:ext cx="10698480" cy="201168"/>
-          </a:xfrm>
-          <a:prstGeom prst="rect">
-            <a:avLst/>
-          </a:prstGeom>
-          <a:noFill/>
-          <a:ln/>
-        </ns0:spPr>
-        <ns0:txBody>
-          <a:bodyPr wrap="square" lIns="0" tIns="0" rIns="0" bIns="0" rtlCol="0" anchor="t"/>
-          <a:lstStyle/>
-          <a:p>
-            <a:pPr indent="0" marL="0">
-              <a:buNone/>
-            </a:pPr>
-            <a:r>
-              <a:rPr lang="en-US" sz="800" i="1" dirty="0">
-                <a:solidFill>
-                  <a:srgbClr val="5B6485"/>
-                </a:solidFill>
-                <a:latin typeface="Calibri" pitchFamily="34" charset="0"/>
-                <a:ea typeface="Calibri" pitchFamily="34" charset="-122"/>
-                <a:cs typeface="Calibri" pitchFamily="34" charset="-120"/>
-              </a:rPr>
-              <a:t>https://www.aisantec.co.jp/ir/investors/   ·   retrieved 7 Jun 2026</a:t>
-            </a:r>
-            <a:endParaRPr lang="en-US" sz="800" dirty="0"/>
-          </a:p>
-        </ns0:txBody>
-      </ns0:sp>
-      <ns0:sp>
-        <ns0:nvSpPr>
-          <ns0:cNvPr id="14" name="Text 12"/>
-          <ns0:cNvSpPr/>
-          <ns0:nvPr/>
-        </ns0:nvSpPr>
-        <ns0:spPr>
-          <a:xfrm>
-            <a:off x="548640" y="3017520"/>
-            <a:ext cx="365760" cy="237744"/>
-          </a:xfrm>
-          <a:prstGeom prst="rect">
-            <a:avLst/>
-          </a:prstGeom>
-          <a:noFill/>
-          <a:ln/>
-        </ns0:spPr>
-        <ns0:txBody>
-          <a:bodyPr wrap="square" lIns="0" tIns="0" rIns="0" bIns="0" rtlCol="0" anchor="t"/>
-          <a:lstStyle/>
-          <a:p>
-            <a:pPr indent="0" marL="0">
-              <a:buNone/>
-            </a:pPr>
-            <a:r>
-              <a:rPr lang="en-US" sz="1100" b="1" dirty="0">
-                <a:solidFill>
-                  <a:srgbClr val="C8A951"/>
-                </a:solidFill>
-                <a:latin typeface="Georgia" pitchFamily="34" charset="0"/>
-                <a:ea typeface="Georgia" pitchFamily="34" charset="-122"/>
-                <a:cs typeface="Georgia" pitchFamily="34" charset="-120"/>
-              </a:rPr>
-              <a:t>4</a:t>
-            </a:r>
-            <a:endParaRPr lang="en-US" sz="1100" dirty="0"/>
-          </a:p>
-        </ns0:txBody>
-      </ns0:sp>
-      <ns0:sp>
-        <ns0:nvSpPr>
-          <ns0:cNvPr id="15" name="Text 13"/>
-          <ns0:cNvSpPr/>
-          <ns0:nvPr/>
-        </ns0:nvSpPr>
-        <ns0:spPr>
-          <a:xfrm>
-            <a:off x="932688" y="3017520"/>
-            <a:ext cx="10698480" cy="274320"/>
-          </a:xfrm>
-          <a:prstGeom prst="rect">
-            <a:avLst/>
-          </a:prstGeom>
-          <a:noFill/>
-          <a:ln/>
-        </ns0:spPr>
-        <ns0:txBody>
-          <a:bodyPr wrap="square" lIns="0" tIns="0" rIns="0" bIns="0" rtlCol="0" anchor="t"/>
-          <a:lstStyle/>
-          <a:p>
-            <a:pPr indent="0" marL="0">
-              <a:lnSpc>
-                <a:spcPct val="95000"/>
-              </a:lnSpc>
-              <a:buNone/>
-            </a:pPr>
-            <a:r>
-              <a:rPr lang="en-US" sz="970" b="1" dirty="0">
-                <a:solidFill>
-                  <a:srgbClr val="1E2761"/>
-                </a:solidFill>
-                <a:latin typeface="Calibri" pitchFamily="34" charset="0"/>
-                <a:ea typeface="Calibri" pitchFamily="34" charset="-122"/>
-                <a:cs typeface="Calibri" pitchFamily="34" charset="-120"/>
-              </a:rPr>
-              <a:t>Nikkei — “アイサン、特別調査委設置 子会社で不適切取引の疑い” (3 Apr 2026)</a:t>
-            </a:r>
-            <a:pPr indent="0" marL="0">
-              <a:lnSpc>
-                <a:spcPct val="95000"/>
-              </a:lnSpc>
-              <a:buNone/>
-            </a:pPr>
-            <a:r>
-              <a:rPr lang="en-US" sz="970" dirty="0">
-                <a:solidFill>
-                  <a:srgbClr val="3A4059"/>
-                </a:solidFill>
-                <a:latin typeface="Calibri" pitchFamily="34" charset="0"/>
-                <a:ea typeface="Calibri" pitchFamily="34" charset="-122"/>
-                <a:cs typeface="Calibri" pitchFamily="34" charset="-120"/>
-              </a:rPr>
-              <a:t>  —  independent confirmation of the investigation</a:t>
-            </a:r>
-            <a:endParaRPr lang="en-US" sz="970" dirty="0"/>
-          </a:p>
-        </ns0:txBody>
-      </ns0:sp>
-      <ns0:sp>
-        <ns0:nvSpPr>
-          <ns0:cNvPr id="16" name="Text 14"/>
-          <ns0:cNvSpPr/>
-          <ns0:nvPr/>
-        </ns0:nvSpPr>
-        <ns0:spPr>
-          <a:xfrm>
-            <a:off x="932688" y="3264408"/>
-            <a:ext cx="10698480" cy="201168"/>
-          </a:xfrm>
-          <a:prstGeom prst="rect">
-            <a:avLst/>
-          </a:prstGeom>
-          <a:noFill/>
-          <a:ln/>
-        </ns0:spPr>
-        <ns0:txBody>
-          <a:bodyPr wrap="square" lIns="0" tIns="0" rIns="0" bIns="0" rtlCol="0" anchor="t"/>
-          <a:lstStyle/>
-          <a:p>
-            <a:pPr indent="0" marL="0">
-              <a:buNone/>
-            </a:pPr>
-            <a:r>
-              <a:rPr lang="en-US" sz="800" i="1" dirty="0">
-                <a:solidFill>
-                  <a:srgbClr val="5B6485"/>
-                </a:solidFill>
-                <a:latin typeface="Calibri" pitchFamily="34" charset="0"/>
-                <a:ea typeface="Calibri" pitchFamily="34" charset="-122"/>
-                <a:cs typeface="Calibri" pitchFamily="34" charset="-120"/>
-              </a:rPr>
-              <a:t>https://www.nikkei.com/nkd/industry/article/?DisplayType=1&amp;n_m_code=146&amp;ng=DGXZQOFD03A3V0T00C26A4000000   ·   retrieved 7 Jun 2026</a:t>
-            </a:r>
-            <a:endParaRPr lang="en-US" sz="800" dirty="0"/>
-          </a:p>
-        </ns0:txBody>
-      </ns0:sp>
-      <ns0:sp>
-        <ns0:nvSpPr>
-          <ns0:cNvPr id="17" name="Text 15"/>
-          <ns0:cNvSpPr/>
-          <ns0:nvPr/>
-        </ns0:nvSpPr>
-        <ns0:spPr>
-          <a:xfrm>
-            <a:off x="548640" y="3566160"/>
-            <a:ext cx="365760" cy="237744"/>
-          </a:xfrm>
-          <a:prstGeom prst="rect">
-            <a:avLst/>
-          </a:prstGeom>
-          <a:noFill/>
-          <a:ln/>
-        </ns0:spPr>
-        <ns0:txBody>
-          <a:bodyPr wrap="square" lIns="0" tIns="0" rIns="0" bIns="0" rtlCol="0" anchor="t"/>
-          <a:lstStyle/>
-          <a:p>
-            <a:pPr indent="0" marL="0">
-              <a:buNone/>
-            </a:pPr>
-            <a:r>
-              <a:rPr lang="en-US" sz="1100" b="1" dirty="0">
-                <a:solidFill>
-                  <a:srgbClr val="C8A951"/>
-                </a:solidFill>
-                <a:latin typeface="Georgia" pitchFamily="34" charset="0"/>
-                <a:ea typeface="Georgia" pitchFamily="34" charset="-122"/>
-                <a:cs typeface="Georgia" pitchFamily="34" charset="-120"/>
-              </a:rPr>
-              <a:t>5</a:t>
-            </a:r>
-            <a:endParaRPr lang="en-US" sz="1100" dirty="0"/>
-          </a:p>
-        </ns0:txBody>
-      </ns0:sp>
-      <ns0:sp>
-        <ns0:nvSpPr>
-          <ns0:cNvPr id="18" name="Text 16"/>
-          <ns0:cNvSpPr/>
-          <ns0:nvPr/>
-        </ns0:nvSpPr>
-        <ns0:spPr>
-          <a:xfrm>
-            <a:off x="932688" y="3566160"/>
-            <a:ext cx="10698480" cy="274320"/>
-          </a:xfrm>
-          <a:prstGeom prst="rect">
-            <a:avLst/>
-          </a:prstGeom>
-          <a:noFill/>
-          <a:ln/>
-        </ns0:spPr>
-        <ns0:txBody>
-          <a:bodyPr wrap="square" lIns="0" tIns="0" rIns="0" bIns="0" rtlCol="0" anchor="t"/>
-          <a:lstStyle/>
-          <a:p>
-            <a:pPr indent="0" marL="0">
-              <a:lnSpc>
-                <a:spcPct val="95000"/>
-              </a:lnSpc>
-              <a:buNone/>
-            </a:pPr>
-            <a:r>
-              <a:rPr lang="en-US" sz="970" b="1" dirty="0">
-                <a:solidFill>
-                  <a:srgbClr val="1E2761"/>
-                </a:solidFill>
-                <a:latin typeface="Calibri" pitchFamily="34" charset="0"/>
-                <a:ea typeface="Calibri" pitchFamily="34" charset="-122"/>
-                <a:cs typeface="Calibri" pitchFamily="34" charset="-120"/>
-              </a:rPr>
-              <a:t>Yahoo Finance JP — market news &amp; quote (4667; Apr 2026)</a:t>
-            </a:r>
-            <a:pPr indent="0" marL="0">
-              <a:lnSpc>
-                <a:spcPct val="95000"/>
-              </a:lnSpc>
-              <a:buNone/>
-            </a:pPr>
-            <a:r>
-              <a:rPr lang="en-US" sz="970" dirty="0">
-                <a:solidFill>
-                  <a:srgbClr val="3A4059"/>
-                </a:solidFill>
-                <a:latin typeface="Calibri" pitchFamily="34" charset="0"/>
-                <a:ea typeface="Calibri" pitchFamily="34" charset="-122"/>
-                <a:cs typeface="Calibri" pitchFamily="34" charset="-120"/>
-              </a:rPr>
-              <a:t>  —  market reaction; ~¥1,643 intraday on disclosure; ~¥1,490s close in May; share price reference</a:t>
-            </a:r>
-            <a:endParaRPr lang="en-US" sz="970" dirty="0"/>
-          </a:p>
-        </ns0:txBody>
-      </ns0:sp>
-      <ns0:sp>
-        <ns0:nvSpPr>
-          <ns0:cNvPr id="19" name="Text 17"/>
-          <ns0:cNvSpPr/>
-          <ns0:nvPr/>
-        </ns0:nvSpPr>
-        <ns0:spPr>
-          <a:xfrm>
-            <a:off x="932688" y="3813048"/>
-            <a:ext cx="10698480" cy="201168"/>
-          </a:xfrm>
-          <a:prstGeom prst="rect">
-            <a:avLst/>
-          </a:prstGeom>
-          <a:noFill/>
-          <a:ln/>
-        </ns0:spPr>
-        <ns0:txBody>
-          <a:bodyPr wrap="square" lIns="0" tIns="0" rIns="0" bIns="0" rtlCol="0" anchor="t"/>
-          <a:lstStyle/>
-          <a:p>
-            <a:pPr indent="0" marL="0">
-              <a:buNone/>
-            </a:pPr>
-            <a:r>
-              <a:rPr lang="en-US" sz="800" i="1" dirty="0">
-                <a:solidFill>
-                  <a:srgbClr val="5B6485"/>
-                </a:solidFill>
-                <a:latin typeface="Calibri" pitchFamily="34" charset="0"/>
-                <a:ea typeface="Calibri" pitchFamily="34" charset="-122"/>
-                <a:cs typeface="Calibri" pitchFamily="34" charset="-120"/>
-              </a:rPr>
-              <a:t>https://finance.yahoo.co.jp/news/detail/5c27f0e1919b1e7001799004888f00d95af6ee3d   ·   retrieved 7 Jun 2026</a:t>
-            </a:r>
-            <a:endParaRPr lang="en-US" sz="800" dirty="0"/>
-          </a:p>
-        </ns0:txBody>
-      </ns0:sp>
-      <ns0:sp>
-        <ns0:nvSpPr>
-          <ns0:cNvPr id="20" name="Text 18"/>
-          <ns0:cNvSpPr/>
-          <ns0:nvPr/>
-        </ns0:nvSpPr>
-        <ns0:spPr>
-          <a:xfrm>
-            <a:off x="548640" y="4114800"/>
-            <a:ext cx="365760" cy="237744"/>
-          </a:xfrm>
-          <a:prstGeom prst="rect">
-            <a:avLst/>
-          </a:prstGeom>
-          <a:noFill/>
-          <a:ln/>
-        </ns0:spPr>
-        <ns0:txBody>
-          <a:bodyPr wrap="square" lIns="0" tIns="0" rIns="0" bIns="0" rtlCol="0" anchor="t"/>
-          <a:lstStyle/>
-          <a:p>
-            <a:pPr indent="0" marL="0">
-              <a:buNone/>
-            </a:pPr>
-            <a:r>
-              <a:rPr lang="en-US" sz="1100" b="1" dirty="0">
-                <a:solidFill>
-                  <a:srgbClr val="C8A951"/>
-                </a:solidFill>
-                <a:latin typeface="Georgia" pitchFamily="34" charset="0"/>
-                <a:ea typeface="Georgia" pitchFamily="34" charset="-122"/>
-                <a:cs typeface="Georgia" pitchFamily="34" charset="-120"/>
-              </a:rPr>
-              <a:t>6</a:t>
-            </a:r>
-            <a:endParaRPr lang="en-US" sz="1100" dirty="0"/>
-          </a:p>
-        </ns0:txBody>
-      </ns0:sp>
-      <ns0:sp>
-        <ns0:nvSpPr>
-          <ns0:cNvPr id="21" name="Text 19"/>
-          <ns0:cNvSpPr/>
-          <ns0:nvPr/>
-        </ns0:nvSpPr>
-        <ns0:spPr>
-          <a:xfrm>
-            <a:off x="932688" y="4114800"/>
-            <a:ext cx="10698480" cy="274320"/>
-          </a:xfrm>
-          <a:prstGeom prst="rect">
-            <a:avLst/>
-          </a:prstGeom>
-          <a:noFill/>
-          <a:ln/>
-        </ns0:spPr>
-        <ns0:txBody>
-          <a:bodyPr wrap="square" lIns="0" tIns="0" rIns="0" bIns="0" rtlCol="0" anchor="t"/>
-          <a:lstStyle/>
-          <a:p>
-            <a:pPr indent="0" marL="0">
-              <a:lnSpc>
-                <a:spcPct val="95000"/>
-              </a:lnSpc>
-              <a:buNone/>
-            </a:pPr>
-            <a:r>
-              <a:rPr lang="en-US" sz="970" b="1" dirty="0">
-                <a:solidFill>
-                  <a:srgbClr val="1E2761"/>
-                </a:solidFill>
-                <a:latin typeface="Calibri" pitchFamily="34" charset="0"/>
-                <a:ea typeface="Calibri" pitchFamily="34" charset="-122"/>
-                <a:cs typeface="Calibri" pitchFamily="34" charset="-120"/>
-              </a:rPr>
-              <a:t>IRBANK — 4667 / E04980 (P&amp;L, balance sheet, cash flow, segment)</a:t>
-            </a:r>
-            <a:pPr indent="0" marL="0">
-              <a:lnSpc>
-                <a:spcPct val="95000"/>
-              </a:lnSpc>
-              <a:buNone/>
-            </a:pPr>
-            <a:r>
-              <a:rPr lang="en-US" sz="970" dirty="0">
-                <a:solidFill>
-                  <a:srgbClr val="3A4059"/>
-                </a:solidFill>
-                <a:latin typeface="Calibri" pitchFamily="34" charset="0"/>
-                <a:ea typeface="Calibri" pitchFamily="34" charset="-122"/>
-                <a:cs typeface="Calibri" pitchFamily="34" charset="-120"/>
-              </a:rPr>
-              <a:t>  —  financial history &amp; multiples (FY24–FY26E)</a:t>
-            </a:r>
-            <a:endParaRPr lang="en-US" sz="970" dirty="0"/>
-          </a:p>
-        </ns0:txBody>
-      </ns0:sp>
-      <ns0:sp>
-        <ns0:nvSpPr>
-          <ns0:cNvPr id="22" name="Text 20"/>
-          <ns0:cNvSpPr/>
-          <ns0:nvPr/>
-        </ns0:nvSpPr>
-        <ns0:spPr>
-          <a:xfrm>
-            <a:off x="932688" y="4361688"/>
-            <a:ext cx="10698480" cy="201168"/>
-          </a:xfrm>
-          <a:prstGeom prst="rect">
-            <a:avLst/>
-          </a:prstGeom>
-          <a:noFill/>
-          <a:ln/>
-        </ns0:spPr>
-        <ns0:txBody>
-          <a:bodyPr wrap="square" lIns="0" tIns="0" rIns="0" bIns="0" rtlCol="0" anchor="t"/>
-          <a:lstStyle/>
-          <a:p>
-            <a:pPr indent="0" marL="0">
-              <a:buNone/>
-            </a:pPr>
-            <a:r>
-              <a:rPr lang="en-US" sz="800" i="1" dirty="0">
-                <a:solidFill>
-                  <a:srgbClr val="5B6485"/>
-                </a:solidFill>
-                <a:latin typeface="Calibri" pitchFamily="34" charset="0"/>
-                <a:ea typeface="Calibri" pitchFamily="34" charset="-122"/>
-                <a:cs typeface="Calibri" pitchFamily="34" charset="-120"/>
-              </a:rPr>
-              <a:t>https://irbank.net/E04980/pl  (also /bs, /cf)   ·   retrieved 7 Jun 2026</a:t>
-            </a:r>
-            <a:endParaRPr lang="en-US" sz="800" dirty="0"/>
-          </a:p>
-        </ns0:txBody>
-      </ns0:sp>
-      <ns0:sp>
-        <ns0:nvSpPr>
-          <ns0:cNvPr id="23" name="Text 21"/>
-          <ns0:cNvSpPr/>
-          <ns0:nvPr/>
-        </ns0:nvSpPr>
-        <ns0:spPr>
-          <a:xfrm>
-            <a:off x="548640" y="4663440"/>
-            <a:ext cx="365760" cy="237744"/>
-          </a:xfrm>
-          <a:prstGeom prst="rect">
-            <a:avLst/>
-          </a:prstGeom>
-          <a:noFill/>
-          <a:ln/>
-        </ns0:spPr>
-        <ns0:txBody>
-          <a:bodyPr wrap="square" lIns="0" tIns="0" rIns="0" bIns="0" rtlCol="0" anchor="t"/>
-          <a:lstStyle/>
-          <a:p>
-            <a:pPr indent="0" marL="0">
-              <a:buNone/>
-            </a:pPr>
-            <a:r>
-              <a:rPr lang="en-US" sz="1100" b="1" dirty="0">
-                <a:solidFill>
-                  <a:srgbClr val="C8A951"/>
-                </a:solidFill>
-                <a:latin typeface="Georgia" pitchFamily="34" charset="0"/>
-                <a:ea typeface="Georgia" pitchFamily="34" charset="-122"/>
-                <a:cs typeface="Georgia" pitchFamily="34" charset="-120"/>
-              </a:rPr>
-              <a:t>7</a:t>
-            </a:r>
-            <a:endParaRPr lang="en-US" sz="1100" dirty="0"/>
-          </a:p>
-        </ns0:txBody>
-      </ns0:sp>
-      <ns0:sp>
-        <ns0:nvSpPr>
-          <ns0:cNvPr id="24" name="Text 22"/>
-          <ns0:cNvSpPr/>
-          <ns0:nvPr/>
-        </ns0:nvSpPr>
-        <ns0:spPr>
-          <a:xfrm>
-            <a:off x="932688" y="4663440"/>
-            <a:ext cx="10698480" cy="274320"/>
-          </a:xfrm>
-          <a:prstGeom prst="rect">
-            <a:avLst/>
-          </a:prstGeom>
-          <a:noFill/>
-          <a:ln/>
-        </ns0:spPr>
-        <ns0:txBody>
-          <a:bodyPr wrap="square" lIns="0" tIns="0" rIns="0" bIns="0" rtlCol="0" anchor="t"/>
-          <a:lstStyle/>
-          <a:p>
-            <a:pPr indent="0" marL="0">
-              <a:lnSpc>
-                <a:spcPct val="95000"/>
-              </a:lnSpc>
-              <a:buNone/>
-            </a:pPr>
-            <a:r>
-              <a:rPr lang="en-US" sz="970" b="1" dirty="0">
-                <a:solidFill>
-                  <a:srgbClr val="1E2761"/>
-                </a:solidFill>
-                <a:latin typeface="Calibri" pitchFamily="34" charset="0"/>
-                <a:ea typeface="Calibri" pitchFamily="34" charset="-122"/>
-                <a:cs typeface="Calibri" pitchFamily="34" charset="-120"/>
-              </a:rPr>
-              <a:t>M&amp;A Online — Akisoku acquisition (Oct 2023; executed Jan 2024)</a:t>
-            </a:r>
-            <a:pPr indent="0" marL="0">
-              <a:lnSpc>
-                <a:spcPct val="95000"/>
-              </a:lnSpc>
-              <a:buNone/>
-            </a:pPr>
-            <a:r>
-              <a:rPr lang="en-US" sz="970" dirty="0">
-                <a:solidFill>
-                  <a:srgbClr val="3A4059"/>
-                </a:solidFill>
-                <a:latin typeface="Calibri" pitchFamily="34" charset="0"/>
-                <a:ea typeface="Calibri" pitchFamily="34" charset="-122"/>
-                <a:cs typeface="Calibri" pitchFamily="34" charset="-120"/>
-              </a:rPr>
-              <a:t>  —  subsidiary acquisition; corporate history</a:t>
-            </a:r>
-            <a:endParaRPr lang="en-US" sz="970" dirty="0"/>
-          </a:p>
-        </ns0:txBody>
-      </ns0:sp>
-      <ns0:sp>
-        <ns0:nvSpPr>
-          <ns0:cNvPr id="25" name="Text 23"/>
-          <ns0:cNvSpPr/>
-          <ns0:nvPr/>
-        </ns0:nvSpPr>
-        <ns0:spPr>
-          <a:xfrm>
-            <a:off x="932688" y="4910328"/>
-            <a:ext cx="10698480" cy="201168"/>
-          </a:xfrm>
-          <a:prstGeom prst="rect">
-            <a:avLst/>
-          </a:prstGeom>
-          <a:noFill/>
-          <a:ln/>
-        </ns0:spPr>
-        <ns0:txBody>
-          <a:bodyPr wrap="square" lIns="0" tIns="0" rIns="0" bIns="0" rtlCol="0" anchor="t"/>
-          <a:lstStyle/>
-          <a:p>
-            <a:pPr indent="0" marL="0">
-              <a:buNone/>
-            </a:pPr>
-            <a:r>
-              <a:rPr lang="en-US" sz="800" i="1" dirty="0">
-                <a:solidFill>
-                  <a:srgbClr val="5B6485"/>
-                </a:solidFill>
-                <a:latin typeface="Calibri" pitchFamily="34" charset="0"/>
-                <a:ea typeface="Calibri" pitchFamily="34" charset="-122"/>
-                <a:cs typeface="Calibri" pitchFamily="34" charset="-120"/>
-              </a:rPr>
-              <a:t>https://maonline.jp/news/20231013b   ·   retrieved 7 Jun 2026</a:t>
-            </a:r>
-            <a:endParaRPr lang="en-US" sz="800" dirty="0"/>
-          </a:p>
-        </ns0:txBody>
-      </ns0:sp>
-      <ns0:sp>
-        <ns0:nvSpPr>
-          <ns0:cNvPr id="26" name="Shape 24"/>
-          <ns0:cNvSpPr/>
-          <ns0:nvPr/>
-        </ns0:nvSpPr>
-        <ns0:spPr>
-          <a:xfrm>
-            <a:off x="548640" y="5285232"/>
-            <a:ext cx="11091672" cy="1078992"/>
-          </a:xfrm>
-          <a:prstGeom prst="roundRect">
-            <a:avLst>
-              <a:gd name="adj" fmla="val 6780"/>
-            </a:avLst>
-          </a:prstGeom>
-          <a:solidFill>
-            <a:srgbClr val="F4F6FB"/>
-          </a:solidFill>
-          <a:ln w="12700">
-            <a:solidFill>
-              <a:srgbClr val="DDE3F0"/>
-            </a:solidFill>
-            <a:prstDash val="solid"/>
-          </a:ln>
-        </ns0:spPr>
-        <ns0:txBody>
-          <a:bodyPr/>
-          <a:p/>
-        </ns0:txBody>
-      </ns0:sp>
-      <ns0:sp>
-        <ns0:nvSpPr>
-          <ns0:cNvPr id="27" name="Shape 25"/>
-          <ns0:cNvSpPr/>
-          <ns0:nvPr/>
-        </ns0:nvSpPr>
-        <ns0:spPr>
-          <a:xfrm>
-            <a:off x="548640" y="5285232"/>
-            <a:ext cx="91440" cy="1078992"/>
-          </a:xfrm>
-          <a:prstGeom prst="roundRect">
-            <a:avLst>
-              <a:gd name="adj" fmla="val 60000"/>
-            </a:avLst>
-          </a:prstGeom>
-          <a:solidFill>
-            <a:srgbClr val="C8A951"/>
-          </a:solidFill>
-          <a:ln/>
-        </ns0:spPr>
-        <ns0:txBody>
-          <a:bodyPr/>
-          <a:p/>
-        </ns0:txBody>
-      </ns0:sp>
-      <ns0:sp>
-        <ns0:nvSpPr>
-          <ns0:cNvPr id="28" name="Text 26"/>
-          <ns0:cNvSpPr/>
-          <ns0:nvPr/>
-        </ns0:nvSpPr>
-        <ns0:spPr>
-          <a:xfrm>
-            <a:off x="868680" y="5376672"/>
-            <a:ext cx="10515600" cy="914400"/>
-          </a:xfrm>
-          <a:prstGeom prst="rect">
-            <a:avLst/>
-          </a:prstGeom>
-          <a:noFill/>
-          <a:ln/>
-        </ns0:spPr>
-        <ns0:txBody>
-          <a:bodyPr wrap="square" lIns="0" tIns="0" rIns="0" bIns="0" rtlCol="0" anchor="ctr"/>
-          <a:lstStyle/>
-          <a:p>
-            <a:r>
-              <a:rPr sz="850"/>
-              <a:t>Reported / estimated / to be verified in DD: founder / related-holder stake, segment margins, peer multiples, investment-securities mark, FY2026E guidance and Akisoku impact. Peer multiples are yfinance snapshots (7-Jun-2026); precedent premia per SECOM/ITOCHU notice (5-Sep-2024) and Topcon disclosure (29-Jul-2025).</a:t>
-            </a:r>
-          </a:p>
-        </ns0:txBody>
-      </ns0:sp>
-      <ns0:sp>
-        <ns0:nvSpPr>
-          <ns0:cNvPr id="29" name="Text 27"/>
-          <ns0:cNvSpPr/>
-          <ns0:nvPr/>
-        </ns0:nvSpPr>
-        <ns0:spPr>
-          <a:xfrm>
-            <a:off x="548640" y="6455664"/>
-            <a:ext cx="7315200" cy="274320"/>
-          </a:xfrm>
-          <a:prstGeom prst="rect">
-            <a:avLst/>
-          </a:prstGeom>
-          <a:noFill/>
-          <a:ln/>
-        </ns0:spPr>
-        <ns0:txBody>
-          <a:bodyPr wrap="square" lIns="0" tIns="0" rIns="0" bIns="0" rtlCol="0" anchor="ctr"/>
-          <a:lstStyle/>
-          <a:p>
-            <a:pPr algn="l" indent="0" marL="0">
-              <a:buNone/>
-            </a:pPr>
-            <a:r>
-              <a:rPr lang="en-US" sz="850" dirty="0">
-                <a:solidFill>
-                  <a:srgbClr val="8A93B2"/>
-                </a:solidFill>
-                <a:latin typeface="Calibri" pitchFamily="34" charset="0"/>
-                <a:ea typeface="Calibri" pitchFamily="34" charset="-122"/>
-                <a:cs typeface="Calibri" pitchFamily="34" charset="-120"/>
-              </a:rPr>
-              <a:t>Project Measure  ·  Strictly Private &amp; Confidential</a:t>
-            </a:r>
-            <a:endParaRPr lang="en-US" sz="850" dirty="0"/>
-          </a:p>
-        </ns0:txBody>
-      </ns0:sp>
-      <ns0:sp>
-        <ns0:nvSpPr>
-          <ns0:cNvPr id="30" name="Text 28"/>
-          <ns0:cNvSpPr/>
-          <ns0:nvPr/>
-        </ns0:nvSpPr>
-        <ns0:spPr>
-          <a:xfrm>
-            <a:off x="11338560" y="6455664"/>
-            <a:ext cx="365760" cy="274320"/>
-          </a:xfrm>
-          <a:prstGeom prst="rect">
-            <a:avLst/>
-          </a:prstGeom>
-          <a:noFill/>
-          <a:ln/>
-        </ns0:spPr>
-        <ns0:txBody>
-          <a:bodyPr wrap="square" lIns="0" tIns="0" rIns="0" bIns="0" rtlCol="0" anchor="ctr"/>
-          <a:lstStyle/>
-          <a:p>
-            <a:r>
-              <a:rPr sz="750"/>
-              <a:t>19</a:t>
-            </a:r>
           </a:p>
         </ns0:txBody>
       </ns0:sp>
@@ -22850,7 +23396,7 @@
                 <a:ea typeface="Calibri" pitchFamily="34" charset="-122"/>
                 <a:cs typeface="Calibri" pitchFamily="34" charset="-120"/>
               </a:rPr>
-              <a:t>Recurring, high-margin surveying-software core (cash cow)</a:t>
+              <a:t>Sticky, high-margin surveying-software core (cash cow; recurring mix TBC)</a:t>
             </a:r>
             <a:endParaRPr lang="en-US" sz="1150" dirty="0"/>
           </a:p>
@@ -22871,7 +23417,7 @@
                 <a:ea typeface="Calibri" pitchFamily="34" charset="-122"/>
                 <a:cs typeface="Calibri" pitchFamily="34" charset="-120"/>
               </a:rPr>
-              <a:t>Over-capitalised balance sheet: ~¥4.1bn net cash to deploy (subject to verification)</a:t>
+              <a:t>Over-capitalised balance sheet: ~¥4.1bn net cash — base case assumes deployment; returns fall to ~12% / ~8% if cash is retained / trapped (DD item)</a:t>
             </a:r>
             <a:endParaRPr lang="en-US" sz="1150" dirty="0"/>
           </a:p>
@@ -23203,6 +23749,1260 @@
               <a:t>2</a:t>
             </a:r>
             <a:endParaRPr lang="en-US" sz="850" dirty="0"/>
+          </a:p>
+        </ns0:txBody>
+      </ns0:sp>
+    </ns0:spTree>
+  </ns0:cSld>
+  <ns0:clrMapOvr>
+    <a:masterClrMapping/>
+  </ns0:clrMapOvr>
+</ns0:sld>
+</file>
+
+<file path=ppt/slides/slide20.xml><?xml version="1.0" encoding="utf-8"?>
+<ns0:sld xmlns:a="http://schemas.openxmlformats.org/drawingml/2006/main" xmlns:ns0="http://schemas.openxmlformats.org/presentationml/2006/main">
+  <ns0:cSld name="Slide 17">
+    <ns0:bg>
+      <ns0:bgPr>
+        <a:solidFill>
+          <a:srgbClr val="FFFFFF"/>
+        </a:solidFill>
+      </ns0:bgPr>
+    </ns0:bg>
+    <ns0:spTree>
+      <ns0:nvGrpSpPr>
+        <ns0:cNvPr id="1" name=""/>
+        <ns0:cNvGrpSpPr/>
+        <ns0:nvPr/>
+      </ns0:nvGrpSpPr>
+      <ns0:grpSpPr>
+        <a:xfrm>
+          <a:off x="0" y="0"/>
+          <a:ext cx="0" cy="0"/>
+          <a:chOff x="0" y="0"/>
+          <a:chExt cx="0" cy="0"/>
+        </a:xfrm>
+      </ns0:grpSpPr>
+      <ns0:sp>
+        <ns0:nvSpPr>
+          <ns0:cNvPr id="2" name="Text 0"/>
+          <ns0:cNvSpPr/>
+          <ns0:nvPr/>
+        </ns0:nvSpPr>
+        <ns0:spPr>
+          <a:xfrm>
+            <a:off x="548640" y="420624"/>
+            <a:ext cx="566928" cy="457200"/>
+          </a:xfrm>
+          <a:prstGeom prst="rect">
+            <a:avLst/>
+          </a:prstGeom>
+          <a:noFill/>
+          <a:ln/>
+        </ns0:spPr>
+        <ns0:txBody>
+          <a:bodyPr wrap="square" lIns="0" tIns="0" rIns="0" bIns="0" rtlCol="0" anchor="t"/>
+          <a:lstStyle/>
+          <a:p>
+            <a:r>
+              <a:rPr sz="1500" b="1">
+                <a:solidFill>
+                  <a:srgbClr val="C8A951"/>
+                </a:solidFill>
+                <a:latin typeface="Georgia"/>
+              </a:rPr>
+              <a:t>A</a:t>
+            </a:r>
+          </a:p>
+        </ns0:txBody>
+      </ns0:sp>
+      <ns0:sp>
+        <ns0:nvSpPr>
+          <ns0:cNvPr id="3" name="Text 1"/>
+          <ns0:cNvSpPr/>
+          <ns0:nvPr/>
+        </ns0:nvSpPr>
+        <ns0:spPr>
+          <a:xfrm>
+            <a:off x="1078992" y="365760"/>
+            <a:ext cx="8778240" cy="566928"/>
+          </a:xfrm>
+          <a:prstGeom prst="rect">
+            <a:avLst/>
+          </a:prstGeom>
+          <a:noFill/>
+          <a:ln/>
+        </ns0:spPr>
+        <ns0:txBody>
+          <a:bodyPr wrap="square" lIns="0" tIns="0" rIns="0" bIns="0" rtlCol="0" anchor="t"/>
+          <a:lstStyle/>
+          <a:p>
+            <a:pPr algn="l" indent="0" marL="0">
+              <a:buNone/>
+            </a:pPr>
+            <a:r>
+              <a:rPr lang="en-US" sz="2700" b="1" dirty="0">
+                <a:solidFill>
+                  <a:srgbClr val="1E2761"/>
+                </a:solidFill>
+                <a:latin typeface="Georgia" pitchFamily="34" charset="0"/>
+                <a:ea typeface="Georgia" pitchFamily="34" charset="-122"/>
+                <a:cs typeface="Georgia" pitchFamily="34" charset="-120"/>
+              </a:rPr>
+              <a:t>Source Appendix</a:t>
+            </a:r>
+            <a:endParaRPr lang="en-US" sz="2700" dirty="0"/>
+          </a:p>
+        </ns0:txBody>
+      </ns0:sp>
+      <ns0:sp>
+        <ns0:nvSpPr>
+          <ns0:cNvPr id="4" name="Text 2"/>
+          <ns0:cNvSpPr/>
+          <ns0:nvPr/>
+        </ns0:nvSpPr>
+        <ns0:spPr>
+          <a:xfrm>
+            <a:off x="1097280" y="914400"/>
+            <a:ext cx="10424160" cy="310896"/>
+          </a:xfrm>
+          <a:prstGeom prst="rect">
+            <a:avLst/>
+          </a:prstGeom>
+          <a:noFill/>
+          <a:ln/>
+        </ns0:spPr>
+        <ns0:txBody>
+          <a:bodyPr wrap="square" lIns="0" tIns="0" rIns="0" bIns="0" rtlCol="0" anchor="t"/>
+          <a:lstStyle/>
+          <a:p>
+            <a:pPr algn="l" indent="0" marL="0">
+              <a:buNone/>
+            </a:pPr>
+            <a:r>
+              <a:rPr lang="en-US" sz="1250" i="1" dirty="0">
+                <a:solidFill>
+                  <a:srgbClr val="5B6485"/>
+                </a:solidFill>
+                <a:latin typeface="Calibri" pitchFamily="34" charset="0"/>
+                <a:ea typeface="Calibri" pitchFamily="34" charset="-122"/>
+                <a:cs typeface="Calibri" pitchFamily="34" charset="-120"/>
+              </a:rPr>
+              <a:t>Selected public sources — every factual claim is to be verified in confirmatory diligence</a:t>
+            </a:r>
+            <a:endParaRPr lang="en-US" sz="1250" dirty="0"/>
+          </a:p>
+        </ns0:txBody>
+      </ns0:sp>
+      <ns0:sp>
+        <ns0:nvSpPr>
+          <ns0:cNvPr id="5" name="Text 3"/>
+          <ns0:cNvSpPr/>
+          <ns0:nvPr/>
+        </ns0:nvSpPr>
+        <ns0:spPr>
+          <a:xfrm>
+            <a:off x="548640" y="1371600"/>
+            <a:ext cx="365760" cy="237744"/>
+          </a:xfrm>
+          <a:prstGeom prst="rect">
+            <a:avLst/>
+          </a:prstGeom>
+          <a:noFill/>
+          <a:ln/>
+        </ns0:spPr>
+        <ns0:txBody>
+          <a:bodyPr wrap="square" lIns="0" tIns="0" rIns="0" bIns="0" rtlCol="0" anchor="t"/>
+          <a:lstStyle/>
+          <a:p>
+            <a:pPr indent="0" marL="0">
+              <a:buNone/>
+            </a:pPr>
+            <a:r>
+              <a:rPr lang="en-US" sz="1100" b="1" dirty="0">
+                <a:solidFill>
+                  <a:srgbClr val="C8A951"/>
+                </a:solidFill>
+                <a:latin typeface="Georgia" pitchFamily="34" charset="0"/>
+                <a:ea typeface="Georgia" pitchFamily="34" charset="-122"/>
+                <a:cs typeface="Georgia" pitchFamily="34" charset="-120"/>
+              </a:rPr>
+              <a:t>1</a:t>
+            </a:r>
+            <a:endParaRPr lang="en-US" sz="1100" dirty="0"/>
+          </a:p>
+        </ns0:txBody>
+      </ns0:sp>
+      <ns0:sp>
+        <ns0:nvSpPr>
+          <ns0:cNvPr id="6" name="Text 4"/>
+          <ns0:cNvSpPr/>
+          <ns0:nvPr/>
+        </ns0:nvSpPr>
+        <ns0:spPr>
+          <a:xfrm>
+            <a:off x="932688" y="1371600"/>
+            <a:ext cx="10698480" cy="274320"/>
+          </a:xfrm>
+          <a:prstGeom prst="rect">
+            <a:avLst/>
+          </a:prstGeom>
+          <a:noFill/>
+          <a:ln/>
+        </ns0:spPr>
+        <ns0:txBody>
+          <a:bodyPr wrap="square" lIns="0" tIns="0" rIns="0" bIns="0" rtlCol="0" anchor="t"/>
+          <a:lstStyle/>
+          <a:p>
+            <a:pPr indent="0" marL="0">
+              <a:lnSpc>
+                <a:spcPct val="95000"/>
+              </a:lnSpc>
+              <a:buNone/>
+            </a:pPr>
+            <a:r>
+              <a:rPr lang="en-US" sz="970" b="1" dirty="0">
+                <a:solidFill>
+                  <a:srgbClr val="1E2761"/>
+                </a:solidFill>
+                <a:latin typeface="Calibri" pitchFamily="34" charset="0"/>
+                <a:ea typeface="Calibri" pitchFamily="34" charset="-122"/>
+                <a:cs typeface="Calibri" pitchFamily="34" charset="-120"/>
+              </a:rPr>
+              <a:t>AISAN IR — Special Investigation Committee notice (3 Apr 2026)</a:t>
+            </a:r>
+            <a:pPr indent="0" marL="0">
+              <a:lnSpc>
+                <a:spcPct val="95000"/>
+              </a:lnSpc>
+              <a:buNone/>
+            </a:pPr>
+            <a:r>
+              <a:rPr lang="en-US" sz="970" dirty="0">
+                <a:solidFill>
+                  <a:srgbClr val="3A4059"/>
+                </a:solidFill>
+                <a:latin typeface="Calibri" pitchFamily="34" charset="0"/>
+                <a:ea typeface="Calibri" pitchFamily="34" charset="-122"/>
+                <a:cs typeface="Calibri" pitchFamily="34" charset="-120"/>
+              </a:rPr>
+              <a:t>  —  subsidiary fraud probe: scope, trigger, committee composition</a:t>
+            </a:r>
+            <a:endParaRPr lang="en-US" sz="970" dirty="0"/>
+          </a:p>
+        </ns0:txBody>
+      </ns0:sp>
+      <ns0:sp>
+        <ns0:nvSpPr>
+          <ns0:cNvPr id="7" name="Text 5"/>
+          <ns0:cNvSpPr/>
+          <ns0:nvPr/>
+        </ns0:nvSpPr>
+        <ns0:spPr>
+          <a:xfrm>
+            <a:off x="932688" y="1618488"/>
+            <a:ext cx="10698480" cy="201168"/>
+          </a:xfrm>
+          <a:prstGeom prst="rect">
+            <a:avLst/>
+          </a:prstGeom>
+          <a:noFill/>
+          <a:ln/>
+        </ns0:spPr>
+        <ns0:txBody>
+          <a:bodyPr wrap="square" lIns="0" tIns="0" rIns="0" bIns="0" rtlCol="0" anchor="t"/>
+          <a:lstStyle/>
+          <a:p>
+            <a:pPr indent="0" marL="0">
+              <a:buNone/>
+            </a:pPr>
+            <a:r>
+              <a:rPr lang="en-US" sz="800" i="1" dirty="0">
+                <a:solidFill>
+                  <a:srgbClr val="5B6485"/>
+                </a:solidFill>
+                <a:latin typeface="Calibri" pitchFamily="34" charset="0"/>
+                <a:ea typeface="Calibri" pitchFamily="34" charset="-122"/>
+                <a:cs typeface="Calibri" pitchFamily="34" charset="-120"/>
+              </a:rPr>
+              <a:t>https://www.aisantec.co.jp/information/4167/   ·   retrieved 7 Jun 2026</a:t>
+            </a:r>
+            <a:endParaRPr lang="en-US" sz="800" dirty="0"/>
+          </a:p>
+        </ns0:txBody>
+      </ns0:sp>
+      <ns0:sp>
+        <ns0:nvSpPr>
+          <ns0:cNvPr id="8" name="Text 6"/>
+          <ns0:cNvSpPr/>
+          <ns0:nvPr/>
+        </ns0:nvSpPr>
+        <ns0:spPr>
+          <a:xfrm>
+            <a:off x="548640" y="1920240"/>
+            <a:ext cx="365760" cy="237744"/>
+          </a:xfrm>
+          <a:prstGeom prst="rect">
+            <a:avLst/>
+          </a:prstGeom>
+          <a:noFill/>
+          <a:ln/>
+        </ns0:spPr>
+        <ns0:txBody>
+          <a:bodyPr wrap="square" lIns="0" tIns="0" rIns="0" bIns="0" rtlCol="0" anchor="t"/>
+          <a:lstStyle/>
+          <a:p>
+            <a:pPr indent="0" marL="0">
+              <a:buNone/>
+            </a:pPr>
+            <a:r>
+              <a:rPr lang="en-US" sz="1100" b="1" dirty="0">
+                <a:solidFill>
+                  <a:srgbClr val="C8A951"/>
+                </a:solidFill>
+                <a:latin typeface="Georgia" pitchFamily="34" charset="0"/>
+                <a:ea typeface="Georgia" pitchFamily="34" charset="-122"/>
+                <a:cs typeface="Georgia" pitchFamily="34" charset="-120"/>
+              </a:rPr>
+              <a:t>2</a:t>
+            </a:r>
+            <a:endParaRPr lang="en-US" sz="1100" dirty="0"/>
+          </a:p>
+        </ns0:txBody>
+      </ns0:sp>
+      <ns0:sp>
+        <ns0:nvSpPr>
+          <ns0:cNvPr id="9" name="Text 7"/>
+          <ns0:cNvSpPr/>
+          <ns0:nvPr/>
+        </ns0:nvSpPr>
+        <ns0:spPr>
+          <a:xfrm>
+            <a:off x="932688" y="1920240"/>
+            <a:ext cx="10698480" cy="274320"/>
+          </a:xfrm>
+          <a:prstGeom prst="rect">
+            <a:avLst/>
+          </a:prstGeom>
+          <a:noFill/>
+          <a:ln/>
+        </ns0:spPr>
+        <ns0:txBody>
+          <a:bodyPr wrap="square" lIns="0" tIns="0" rIns="0" bIns="0" rtlCol="0" anchor="t"/>
+          <a:lstStyle/>
+          <a:p>
+            <a:pPr indent="0" marL="0">
+              <a:lnSpc>
+                <a:spcPct val="95000"/>
+              </a:lnSpc>
+              <a:buNone/>
+            </a:pPr>
+            <a:r>
+              <a:rPr lang="en-US" sz="970" b="1" dirty="0">
+                <a:solidFill>
+                  <a:srgbClr val="1E2761"/>
+                </a:solidFill>
+                <a:latin typeface="Calibri" pitchFamily="34" charset="0"/>
+                <a:ea typeface="Calibri" pitchFamily="34" charset="-122"/>
+                <a:cs typeface="Calibri" pitchFamily="34" charset="-120"/>
+              </a:rPr>
+              <a:t>AISAN IR — share status / major shareholders</a:t>
+            </a:r>
+            <a:pPr indent="0" marL="0">
+              <a:lnSpc>
+                <a:spcPct val="95000"/>
+              </a:lnSpc>
+              <a:buNone/>
+            </a:pPr>
+            <a:r>
+              <a:rPr lang="en-US" sz="970" dirty="0">
+                <a:solidFill>
+                  <a:srgbClr val="3A4059"/>
+                </a:solidFill>
+                <a:latin typeface="Calibri" pitchFamily="34" charset="0"/>
+                <a:ea typeface="Calibri" pitchFamily="34" charset="-122"/>
+                <a:cs typeface="Calibri" pitchFamily="34" charset="-120"/>
+              </a:rPr>
+              <a:t>  —  issued shares 5,548,979; treasury shares 268,816; top holders</a:t>
+            </a:r>
+            <a:endParaRPr lang="en-US" sz="970" dirty="0"/>
+          </a:p>
+        </ns0:txBody>
+      </ns0:sp>
+      <ns0:sp>
+        <ns0:nvSpPr>
+          <ns0:cNvPr id="10" name="Text 8"/>
+          <ns0:cNvSpPr/>
+          <ns0:nvPr/>
+        </ns0:nvSpPr>
+        <ns0:spPr>
+          <a:xfrm>
+            <a:off x="932688" y="2167128"/>
+            <a:ext cx="10698480" cy="201168"/>
+          </a:xfrm>
+          <a:prstGeom prst="rect">
+            <a:avLst/>
+          </a:prstGeom>
+          <a:noFill/>
+          <a:ln/>
+        </ns0:spPr>
+        <ns0:txBody>
+          <a:bodyPr wrap="square" lIns="0" tIns="0" rIns="0" bIns="0" rtlCol="0" anchor="t"/>
+          <a:lstStyle/>
+          <a:p>
+            <a:pPr indent="0" marL="0">
+              <a:buNone/>
+            </a:pPr>
+            <a:r>
+              <a:rPr lang="en-US" sz="800" i="1" dirty="0">
+                <a:solidFill>
+                  <a:srgbClr val="5B6485"/>
+                </a:solidFill>
+                <a:latin typeface="Calibri" pitchFamily="34" charset="0"/>
+                <a:ea typeface="Calibri" pitchFamily="34" charset="-122"/>
+                <a:cs typeface="Calibri" pitchFamily="34" charset="-120"/>
+              </a:rPr>
+              <a:t>https://www.aisantec.co.jp/ir/stock/status/   ·   retrieved 7 Jun 2026</a:t>
+            </a:r>
+            <a:endParaRPr lang="en-US" sz="800" dirty="0"/>
+          </a:p>
+        </ns0:txBody>
+      </ns0:sp>
+      <ns0:sp>
+        <ns0:nvSpPr>
+          <ns0:cNvPr id="11" name="Text 9"/>
+          <ns0:cNvSpPr/>
+          <ns0:nvPr/>
+        </ns0:nvSpPr>
+        <ns0:spPr>
+          <a:xfrm>
+            <a:off x="548640" y="2468880"/>
+            <a:ext cx="365760" cy="237744"/>
+          </a:xfrm>
+          <a:prstGeom prst="rect">
+            <a:avLst/>
+          </a:prstGeom>
+          <a:noFill/>
+          <a:ln/>
+        </ns0:spPr>
+        <ns0:txBody>
+          <a:bodyPr wrap="square" lIns="0" tIns="0" rIns="0" bIns="0" rtlCol="0" anchor="t"/>
+          <a:lstStyle/>
+          <a:p>
+            <a:pPr indent="0" marL="0">
+              <a:buNone/>
+            </a:pPr>
+            <a:r>
+              <a:rPr lang="en-US" sz="1100" b="1" dirty="0">
+                <a:solidFill>
+                  <a:srgbClr val="C8A951"/>
+                </a:solidFill>
+                <a:latin typeface="Georgia" pitchFamily="34" charset="0"/>
+                <a:ea typeface="Georgia" pitchFamily="34" charset="-122"/>
+                <a:cs typeface="Georgia" pitchFamily="34" charset="-120"/>
+              </a:rPr>
+              <a:t>3</a:t>
+            </a:r>
+            <a:endParaRPr lang="en-US" sz="1100" dirty="0"/>
+          </a:p>
+        </ns0:txBody>
+      </ns0:sp>
+      <ns0:sp>
+        <ns0:nvSpPr>
+          <ns0:cNvPr id="12" name="Text 10"/>
+          <ns0:cNvSpPr/>
+          <ns0:nvPr/>
+        </ns0:nvSpPr>
+        <ns0:spPr>
+          <a:xfrm>
+            <a:off x="932688" y="2468880"/>
+            <a:ext cx="10698480" cy="274320"/>
+          </a:xfrm>
+          <a:prstGeom prst="rect">
+            <a:avLst/>
+          </a:prstGeom>
+          <a:noFill/>
+          <a:ln/>
+        </ns0:spPr>
+        <ns0:txBody>
+          <a:bodyPr wrap="square" lIns="0" tIns="0" rIns="0" bIns="0" rtlCol="0" anchor="t"/>
+          <a:lstStyle/>
+          <a:p>
+            <a:pPr indent="0" marL="0">
+              <a:lnSpc>
+                <a:spcPct val="95000"/>
+              </a:lnSpc>
+              <a:buNone/>
+            </a:pPr>
+            <a:r>
+              <a:rPr lang="en-US" sz="970" b="1" dirty="0">
+                <a:solidFill>
+                  <a:srgbClr val="1E2761"/>
+                </a:solidFill>
+                <a:latin typeface="Calibri" pitchFamily="34" charset="0"/>
+                <a:ea typeface="Calibri" pitchFamily="34" charset="-122"/>
+                <a:cs typeface="Calibri" pitchFamily="34" charset="-120"/>
+              </a:rPr>
+              <a:t>AISAN IR — FY2025 results &amp; FY2026 guidance (決算短信; results normally announced May)</a:t>
+            </a:r>
+            <a:pPr indent="0" marL="0">
+              <a:lnSpc>
+                <a:spcPct val="95000"/>
+              </a:lnSpc>
+              <a:buNone/>
+            </a:pPr>
+            <a:r>
+              <a:rPr lang="en-US" sz="970" dirty="0">
+                <a:solidFill>
+                  <a:srgbClr val="3A4059"/>
+                </a:solidFill>
+                <a:latin typeface="Calibri" pitchFamily="34" charset="0"/>
+                <a:ea typeface="Calibri" pitchFamily="34" charset="-122"/>
+                <a:cs typeface="Calibri" pitchFamily="34" charset="-120"/>
+              </a:rPr>
+              <a:t>  —  FY25A rev ¥6.22bn / OP ¥0.44bn; FY26E guidance ¥7.2bn / ¥0.6bn; FY26 results delayed (30-Apr-26 notice)</a:t>
+            </a:r>
+            <a:endParaRPr lang="en-US" sz="970" dirty="0"/>
+          </a:p>
+        </ns0:txBody>
+      </ns0:sp>
+      <ns0:sp>
+        <ns0:nvSpPr>
+          <ns0:cNvPr id="13" name="Text 11"/>
+          <ns0:cNvSpPr/>
+          <ns0:nvPr/>
+        </ns0:nvSpPr>
+        <ns0:spPr>
+          <a:xfrm>
+            <a:off x="932688" y="2715768"/>
+            <a:ext cx="10698480" cy="201168"/>
+          </a:xfrm>
+          <a:prstGeom prst="rect">
+            <a:avLst/>
+          </a:prstGeom>
+          <a:noFill/>
+          <a:ln/>
+        </ns0:spPr>
+        <ns0:txBody>
+          <a:bodyPr wrap="square" lIns="0" tIns="0" rIns="0" bIns="0" rtlCol="0" anchor="t"/>
+          <a:lstStyle/>
+          <a:p>
+            <a:pPr indent="0" marL="0">
+              <a:buNone/>
+            </a:pPr>
+            <a:r>
+              <a:rPr lang="en-US" sz="800" i="1" dirty="0">
+                <a:solidFill>
+                  <a:srgbClr val="5B6485"/>
+                </a:solidFill>
+                <a:latin typeface="Calibri" pitchFamily="34" charset="0"/>
+                <a:ea typeface="Calibri" pitchFamily="34" charset="-122"/>
+                <a:cs typeface="Calibri" pitchFamily="34" charset="-120"/>
+              </a:rPr>
+              <a:t>https://www.aisantec.co.jp/ir/investors/   ·   FY26 delay notice: https://irbank.net/4667/140120260430514374   ·   retrieved 7 Jun 2026</a:t>
+            </a:r>
+            <a:endParaRPr lang="en-US" sz="800" dirty="0"/>
+          </a:p>
+        </ns0:txBody>
+      </ns0:sp>
+      <ns0:sp>
+        <ns0:nvSpPr>
+          <ns0:cNvPr id="14" name="Text 12"/>
+          <ns0:cNvSpPr/>
+          <ns0:nvPr/>
+        </ns0:nvSpPr>
+        <ns0:spPr>
+          <a:xfrm>
+            <a:off x="548640" y="3017520"/>
+            <a:ext cx="365760" cy="237744"/>
+          </a:xfrm>
+          <a:prstGeom prst="rect">
+            <a:avLst/>
+          </a:prstGeom>
+          <a:noFill/>
+          <a:ln/>
+        </ns0:spPr>
+        <ns0:txBody>
+          <a:bodyPr wrap="square" lIns="0" tIns="0" rIns="0" bIns="0" rtlCol="0" anchor="t"/>
+          <a:lstStyle/>
+          <a:p>
+            <a:pPr indent="0" marL="0">
+              <a:buNone/>
+            </a:pPr>
+            <a:r>
+              <a:rPr lang="en-US" sz="1100" b="1" dirty="0">
+                <a:solidFill>
+                  <a:srgbClr val="C8A951"/>
+                </a:solidFill>
+                <a:latin typeface="Georgia" pitchFamily="34" charset="0"/>
+                <a:ea typeface="Georgia" pitchFamily="34" charset="-122"/>
+                <a:cs typeface="Georgia" pitchFamily="34" charset="-120"/>
+              </a:rPr>
+              <a:t>4</a:t>
+            </a:r>
+            <a:endParaRPr lang="en-US" sz="1100" dirty="0"/>
+          </a:p>
+        </ns0:txBody>
+      </ns0:sp>
+      <ns0:sp>
+        <ns0:nvSpPr>
+          <ns0:cNvPr id="15" name="Text 13"/>
+          <ns0:cNvSpPr/>
+          <ns0:nvPr/>
+        </ns0:nvSpPr>
+        <ns0:spPr>
+          <a:xfrm>
+            <a:off x="932688" y="3017520"/>
+            <a:ext cx="10698480" cy="274320"/>
+          </a:xfrm>
+          <a:prstGeom prst="rect">
+            <a:avLst/>
+          </a:prstGeom>
+          <a:noFill/>
+          <a:ln/>
+        </ns0:spPr>
+        <ns0:txBody>
+          <a:bodyPr wrap="square" lIns="0" tIns="0" rIns="0" bIns="0" rtlCol="0" anchor="t"/>
+          <a:lstStyle/>
+          <a:p>
+            <a:pPr indent="0" marL="0">
+              <a:lnSpc>
+                <a:spcPct val="95000"/>
+              </a:lnSpc>
+              <a:buNone/>
+            </a:pPr>
+            <a:r>
+              <a:rPr lang="en-US" sz="970" b="1" dirty="0">
+                <a:solidFill>
+                  <a:srgbClr val="1E2761"/>
+                </a:solidFill>
+                <a:latin typeface="Calibri" pitchFamily="34" charset="0"/>
+                <a:ea typeface="Calibri" pitchFamily="34" charset="-122"/>
+                <a:cs typeface="Calibri" pitchFamily="34" charset="-120"/>
+              </a:rPr>
+              <a:t>Nikkei — “アイサン、特別調査委設置 子会社で不適切取引の疑い” (3 Apr 2026)</a:t>
+            </a:r>
+            <a:pPr indent="0" marL="0">
+              <a:lnSpc>
+                <a:spcPct val="95000"/>
+              </a:lnSpc>
+              <a:buNone/>
+            </a:pPr>
+            <a:r>
+              <a:rPr lang="en-US" sz="970" dirty="0">
+                <a:solidFill>
+                  <a:srgbClr val="3A4059"/>
+                </a:solidFill>
+                <a:latin typeface="Calibri" pitchFamily="34" charset="0"/>
+                <a:ea typeface="Calibri" pitchFamily="34" charset="-122"/>
+                <a:cs typeface="Calibri" pitchFamily="34" charset="-120"/>
+              </a:rPr>
+              <a:t>  —  independent confirmation of the investigation</a:t>
+            </a:r>
+            <a:endParaRPr lang="en-US" sz="970" dirty="0"/>
+          </a:p>
+        </ns0:txBody>
+      </ns0:sp>
+      <ns0:sp>
+        <ns0:nvSpPr>
+          <ns0:cNvPr id="16" name="Text 14"/>
+          <ns0:cNvSpPr/>
+          <ns0:nvPr/>
+        </ns0:nvSpPr>
+        <ns0:spPr>
+          <a:xfrm>
+            <a:off x="932688" y="3264408"/>
+            <a:ext cx="10698480" cy="201168"/>
+          </a:xfrm>
+          <a:prstGeom prst="rect">
+            <a:avLst/>
+          </a:prstGeom>
+          <a:noFill/>
+          <a:ln/>
+        </ns0:spPr>
+        <ns0:txBody>
+          <a:bodyPr wrap="square" lIns="0" tIns="0" rIns="0" bIns="0" rtlCol="0" anchor="t"/>
+          <a:lstStyle/>
+          <a:p>
+            <a:pPr indent="0" marL="0">
+              <a:buNone/>
+            </a:pPr>
+            <a:r>
+              <a:rPr lang="en-US" sz="800" i="1" dirty="0">
+                <a:solidFill>
+                  <a:srgbClr val="5B6485"/>
+                </a:solidFill>
+                <a:latin typeface="Calibri" pitchFamily="34" charset="0"/>
+                <a:ea typeface="Calibri" pitchFamily="34" charset="-122"/>
+                <a:cs typeface="Calibri" pitchFamily="34" charset="-120"/>
+              </a:rPr>
+              <a:t>https://www.nikkei.com/nkd/industry/article/?DisplayType=1&amp;n_m_code=146&amp;ng=DGXZQOFD03A3V0T00C26A4000000   ·   retrieved 7 Jun 2026</a:t>
+            </a:r>
+            <a:endParaRPr lang="en-US" sz="800" dirty="0"/>
+          </a:p>
+        </ns0:txBody>
+      </ns0:sp>
+      <ns0:sp>
+        <ns0:nvSpPr>
+          <ns0:cNvPr id="17" name="Text 15"/>
+          <ns0:cNvSpPr/>
+          <ns0:nvPr/>
+        </ns0:nvSpPr>
+        <ns0:spPr>
+          <a:xfrm>
+            <a:off x="548640" y="3566160"/>
+            <a:ext cx="365760" cy="237744"/>
+          </a:xfrm>
+          <a:prstGeom prst="rect">
+            <a:avLst/>
+          </a:prstGeom>
+          <a:noFill/>
+          <a:ln/>
+        </ns0:spPr>
+        <ns0:txBody>
+          <a:bodyPr wrap="square" lIns="0" tIns="0" rIns="0" bIns="0" rtlCol="0" anchor="t"/>
+          <a:lstStyle/>
+          <a:p>
+            <a:pPr indent="0" marL="0">
+              <a:buNone/>
+            </a:pPr>
+            <a:r>
+              <a:rPr lang="en-US" sz="1100" b="1" dirty="0">
+                <a:solidFill>
+                  <a:srgbClr val="C8A951"/>
+                </a:solidFill>
+                <a:latin typeface="Georgia" pitchFamily="34" charset="0"/>
+                <a:ea typeface="Georgia" pitchFamily="34" charset="-122"/>
+                <a:cs typeface="Georgia" pitchFamily="34" charset="-120"/>
+              </a:rPr>
+              <a:t>5</a:t>
+            </a:r>
+            <a:endParaRPr lang="en-US" sz="1100" dirty="0"/>
+          </a:p>
+        </ns0:txBody>
+      </ns0:sp>
+      <ns0:sp>
+        <ns0:nvSpPr>
+          <ns0:cNvPr id="18" name="Text 16"/>
+          <ns0:cNvSpPr/>
+          <ns0:nvPr/>
+        </ns0:nvSpPr>
+        <ns0:spPr>
+          <a:xfrm>
+            <a:off x="932688" y="3566160"/>
+            <a:ext cx="10698480" cy="274320"/>
+          </a:xfrm>
+          <a:prstGeom prst="rect">
+            <a:avLst/>
+          </a:prstGeom>
+          <a:noFill/>
+          <a:ln/>
+        </ns0:spPr>
+        <ns0:txBody>
+          <a:bodyPr wrap="square" lIns="0" tIns="0" rIns="0" bIns="0" rtlCol="0" anchor="t"/>
+          <a:lstStyle/>
+          <a:p>
+            <a:pPr indent="0" marL="0">
+              <a:lnSpc>
+                <a:spcPct val="95000"/>
+              </a:lnSpc>
+              <a:buNone/>
+            </a:pPr>
+            <a:r>
+              <a:rPr lang="en-US" sz="970" b="1" dirty="0">
+                <a:solidFill>
+                  <a:srgbClr val="1E2761"/>
+                </a:solidFill>
+                <a:latin typeface="Calibri" pitchFamily="34" charset="0"/>
+                <a:ea typeface="Calibri" pitchFamily="34" charset="-122"/>
+                <a:cs typeface="Calibri" pitchFamily="34" charset="-120"/>
+              </a:rPr>
+              <a:t>Yahoo Finance JP — market news &amp; quote (4667; Apr 2026)</a:t>
+            </a:r>
+            <a:pPr indent="0" marL="0">
+              <a:lnSpc>
+                <a:spcPct val="95000"/>
+              </a:lnSpc>
+              <a:buNone/>
+            </a:pPr>
+            <a:r>
+              <a:rPr lang="en-US" sz="970" dirty="0">
+                <a:solidFill>
+                  <a:srgbClr val="3A4059"/>
+                </a:solidFill>
+                <a:latin typeface="Calibri" pitchFamily="34" charset="0"/>
+                <a:ea typeface="Calibri" pitchFamily="34" charset="-122"/>
+                <a:cs typeface="Calibri" pitchFamily="34" charset="-120"/>
+              </a:rPr>
+              <a:t>  —  market reaction; ~¥1,643 intraday on disclosure; ~¥1,490s close in May; share price reference</a:t>
+            </a:r>
+            <a:endParaRPr lang="en-US" sz="970" dirty="0"/>
+          </a:p>
+        </ns0:txBody>
+      </ns0:sp>
+      <ns0:sp>
+        <ns0:nvSpPr>
+          <ns0:cNvPr id="19" name="Text 17"/>
+          <ns0:cNvSpPr/>
+          <ns0:nvPr/>
+        </ns0:nvSpPr>
+        <ns0:spPr>
+          <a:xfrm>
+            <a:off x="932688" y="3813048"/>
+            <a:ext cx="10698480" cy="201168"/>
+          </a:xfrm>
+          <a:prstGeom prst="rect">
+            <a:avLst/>
+          </a:prstGeom>
+          <a:noFill/>
+          <a:ln/>
+        </ns0:spPr>
+        <ns0:txBody>
+          <a:bodyPr wrap="square" lIns="0" tIns="0" rIns="0" bIns="0" rtlCol="0" anchor="t"/>
+          <a:lstStyle/>
+          <a:p>
+            <a:pPr indent="0" marL="0">
+              <a:buNone/>
+            </a:pPr>
+            <a:r>
+              <a:rPr lang="en-US" sz="800" i="1" dirty="0">
+                <a:solidFill>
+                  <a:srgbClr val="5B6485"/>
+                </a:solidFill>
+                <a:latin typeface="Calibri" pitchFamily="34" charset="0"/>
+                <a:ea typeface="Calibri" pitchFamily="34" charset="-122"/>
+                <a:cs typeface="Calibri" pitchFamily="34" charset="-120"/>
+              </a:rPr>
+              <a:t>https://finance.yahoo.co.jp/news/detail/5c27f0e1919b1e7001799004888f00d95af6ee3d   ·   retrieved 7 Jun 2026</a:t>
+            </a:r>
+            <a:endParaRPr lang="en-US" sz="800" dirty="0"/>
+          </a:p>
+        </ns0:txBody>
+      </ns0:sp>
+      <ns0:sp>
+        <ns0:nvSpPr>
+          <ns0:cNvPr id="20" name="Text 18"/>
+          <ns0:cNvSpPr/>
+          <ns0:nvPr/>
+        </ns0:nvSpPr>
+        <ns0:spPr>
+          <a:xfrm>
+            <a:off x="548640" y="4114800"/>
+            <a:ext cx="365760" cy="237744"/>
+          </a:xfrm>
+          <a:prstGeom prst="rect">
+            <a:avLst/>
+          </a:prstGeom>
+          <a:noFill/>
+          <a:ln/>
+        </ns0:spPr>
+        <ns0:txBody>
+          <a:bodyPr wrap="square" lIns="0" tIns="0" rIns="0" bIns="0" rtlCol="0" anchor="t"/>
+          <a:lstStyle/>
+          <a:p>
+            <a:pPr indent="0" marL="0">
+              <a:buNone/>
+            </a:pPr>
+            <a:r>
+              <a:rPr lang="en-US" sz="1100" b="1" dirty="0">
+                <a:solidFill>
+                  <a:srgbClr val="C8A951"/>
+                </a:solidFill>
+                <a:latin typeface="Georgia" pitchFamily="34" charset="0"/>
+                <a:ea typeface="Georgia" pitchFamily="34" charset="-122"/>
+                <a:cs typeface="Georgia" pitchFamily="34" charset="-120"/>
+              </a:rPr>
+              <a:t>6</a:t>
+            </a:r>
+            <a:endParaRPr lang="en-US" sz="1100" dirty="0"/>
+          </a:p>
+        </ns0:txBody>
+      </ns0:sp>
+      <ns0:sp>
+        <ns0:nvSpPr>
+          <ns0:cNvPr id="21" name="Text 19"/>
+          <ns0:cNvSpPr/>
+          <ns0:nvPr/>
+        </ns0:nvSpPr>
+        <ns0:spPr>
+          <a:xfrm>
+            <a:off x="932688" y="4114800"/>
+            <a:ext cx="10698480" cy="274320"/>
+          </a:xfrm>
+          <a:prstGeom prst="rect">
+            <a:avLst/>
+          </a:prstGeom>
+          <a:noFill/>
+          <a:ln/>
+        </ns0:spPr>
+        <ns0:txBody>
+          <a:bodyPr wrap="square" lIns="0" tIns="0" rIns="0" bIns="0" rtlCol="0" anchor="t"/>
+          <a:lstStyle/>
+          <a:p>
+            <a:pPr indent="0" marL="0">
+              <a:lnSpc>
+                <a:spcPct val="95000"/>
+              </a:lnSpc>
+              <a:buNone/>
+            </a:pPr>
+            <a:r>
+              <a:rPr lang="en-US" sz="970" b="1" dirty="0">
+                <a:solidFill>
+                  <a:srgbClr val="1E2761"/>
+                </a:solidFill>
+                <a:latin typeface="Calibri" pitchFamily="34" charset="0"/>
+                <a:ea typeface="Calibri" pitchFamily="34" charset="-122"/>
+                <a:cs typeface="Calibri" pitchFamily="34" charset="-120"/>
+              </a:rPr>
+              <a:t>IRBANK — 4667 / E04980 (P&amp;L, balance sheet, cash flow, segment)</a:t>
+            </a:r>
+            <a:pPr indent="0" marL="0">
+              <a:lnSpc>
+                <a:spcPct val="95000"/>
+              </a:lnSpc>
+              <a:buNone/>
+            </a:pPr>
+            <a:r>
+              <a:rPr lang="en-US" sz="970" dirty="0">
+                <a:solidFill>
+                  <a:srgbClr val="3A4059"/>
+                </a:solidFill>
+                <a:latin typeface="Calibri" pitchFamily="34" charset="0"/>
+                <a:ea typeface="Calibri" pitchFamily="34" charset="-122"/>
+                <a:cs typeface="Calibri" pitchFamily="34" charset="-120"/>
+              </a:rPr>
+              <a:t>  —  financial history &amp; multiples (FY24–FY26E)</a:t>
+            </a:r>
+            <a:endParaRPr lang="en-US" sz="970" dirty="0"/>
+          </a:p>
+        </ns0:txBody>
+      </ns0:sp>
+      <ns0:sp>
+        <ns0:nvSpPr>
+          <ns0:cNvPr id="22" name="Text 20"/>
+          <ns0:cNvSpPr/>
+          <ns0:nvPr/>
+        </ns0:nvSpPr>
+        <ns0:spPr>
+          <a:xfrm>
+            <a:off x="932688" y="4361688"/>
+            <a:ext cx="10698480" cy="201168"/>
+          </a:xfrm>
+          <a:prstGeom prst="rect">
+            <a:avLst/>
+          </a:prstGeom>
+          <a:noFill/>
+          <a:ln/>
+        </ns0:spPr>
+        <ns0:txBody>
+          <a:bodyPr wrap="square" lIns="0" tIns="0" rIns="0" bIns="0" rtlCol="0" anchor="t"/>
+          <a:lstStyle/>
+          <a:p>
+            <a:pPr indent="0" marL="0">
+              <a:buNone/>
+            </a:pPr>
+            <a:r>
+              <a:rPr lang="en-US" sz="800" i="1" dirty="0">
+                <a:solidFill>
+                  <a:srgbClr val="5B6485"/>
+                </a:solidFill>
+                <a:latin typeface="Calibri" pitchFamily="34" charset="0"/>
+                <a:ea typeface="Calibri" pitchFamily="34" charset="-122"/>
+                <a:cs typeface="Calibri" pitchFamily="34" charset="-120"/>
+              </a:rPr>
+              <a:t>https://irbank.net/E04980/pl  (also /bs, /cf)   ·   retrieved 7 Jun 2026</a:t>
+            </a:r>
+            <a:endParaRPr lang="en-US" sz="800" dirty="0"/>
+          </a:p>
+        </ns0:txBody>
+      </ns0:sp>
+      <ns0:sp>
+        <ns0:nvSpPr>
+          <ns0:cNvPr id="23" name="Text 21"/>
+          <ns0:cNvSpPr/>
+          <ns0:nvPr/>
+        </ns0:nvSpPr>
+        <ns0:spPr>
+          <a:xfrm>
+            <a:off x="548640" y="4663440"/>
+            <a:ext cx="365760" cy="237744"/>
+          </a:xfrm>
+          <a:prstGeom prst="rect">
+            <a:avLst/>
+          </a:prstGeom>
+          <a:noFill/>
+          <a:ln/>
+        </ns0:spPr>
+        <ns0:txBody>
+          <a:bodyPr wrap="square" lIns="0" tIns="0" rIns="0" bIns="0" rtlCol="0" anchor="t"/>
+          <a:lstStyle/>
+          <a:p>
+            <a:pPr indent="0" marL="0">
+              <a:buNone/>
+            </a:pPr>
+            <a:r>
+              <a:rPr lang="en-US" sz="1100" b="1" dirty="0">
+                <a:solidFill>
+                  <a:srgbClr val="C8A951"/>
+                </a:solidFill>
+                <a:latin typeface="Georgia" pitchFamily="34" charset="0"/>
+                <a:ea typeface="Georgia" pitchFamily="34" charset="-122"/>
+                <a:cs typeface="Georgia" pitchFamily="34" charset="-120"/>
+              </a:rPr>
+              <a:t>7</a:t>
+            </a:r>
+            <a:endParaRPr lang="en-US" sz="1100" dirty="0"/>
+          </a:p>
+        </ns0:txBody>
+      </ns0:sp>
+      <ns0:sp>
+        <ns0:nvSpPr>
+          <ns0:cNvPr id="24" name="Text 22"/>
+          <ns0:cNvSpPr/>
+          <ns0:nvPr/>
+        </ns0:nvSpPr>
+        <ns0:spPr>
+          <a:xfrm>
+            <a:off x="932688" y="4663440"/>
+            <a:ext cx="10698480" cy="274320"/>
+          </a:xfrm>
+          <a:prstGeom prst="rect">
+            <a:avLst/>
+          </a:prstGeom>
+          <a:noFill/>
+          <a:ln/>
+        </ns0:spPr>
+        <ns0:txBody>
+          <a:bodyPr wrap="square" lIns="0" tIns="0" rIns="0" bIns="0" rtlCol="0" anchor="t"/>
+          <a:lstStyle/>
+          <a:p>
+            <a:pPr indent="0" marL="0">
+              <a:lnSpc>
+                <a:spcPct val="95000"/>
+              </a:lnSpc>
+              <a:buNone/>
+            </a:pPr>
+            <a:r>
+              <a:rPr lang="en-US" sz="970" b="1" dirty="0">
+                <a:solidFill>
+                  <a:srgbClr val="1E2761"/>
+                </a:solidFill>
+                <a:latin typeface="Calibri" pitchFamily="34" charset="0"/>
+                <a:ea typeface="Calibri" pitchFamily="34" charset="-122"/>
+                <a:cs typeface="Calibri" pitchFamily="34" charset="-120"/>
+              </a:rPr>
+              <a:t>M&amp;A Online — Akisoku acquisition (Oct 2023; executed Jan 2024)</a:t>
+            </a:r>
+            <a:pPr indent="0" marL="0">
+              <a:lnSpc>
+                <a:spcPct val="95000"/>
+              </a:lnSpc>
+              <a:buNone/>
+            </a:pPr>
+            <a:r>
+              <a:rPr lang="en-US" sz="970" dirty="0">
+                <a:solidFill>
+                  <a:srgbClr val="3A4059"/>
+                </a:solidFill>
+                <a:latin typeface="Calibri" pitchFamily="34" charset="0"/>
+                <a:ea typeface="Calibri" pitchFamily="34" charset="-122"/>
+                <a:cs typeface="Calibri" pitchFamily="34" charset="-120"/>
+              </a:rPr>
+              <a:t>  —  subsidiary acquisition; corporate history</a:t>
+            </a:r>
+            <a:endParaRPr lang="en-US" sz="970" dirty="0"/>
+          </a:p>
+        </ns0:txBody>
+      </ns0:sp>
+      <ns0:sp>
+        <ns0:nvSpPr>
+          <ns0:cNvPr id="25" name="Text 23"/>
+          <ns0:cNvSpPr/>
+          <ns0:nvPr/>
+        </ns0:nvSpPr>
+        <ns0:spPr>
+          <a:xfrm>
+            <a:off x="932688" y="4910328"/>
+            <a:ext cx="10698480" cy="201168"/>
+          </a:xfrm>
+          <a:prstGeom prst="rect">
+            <a:avLst/>
+          </a:prstGeom>
+          <a:noFill/>
+          <a:ln/>
+        </ns0:spPr>
+        <ns0:txBody>
+          <a:bodyPr wrap="square" lIns="0" tIns="0" rIns="0" bIns="0" rtlCol="0" anchor="t"/>
+          <a:lstStyle/>
+          <a:p>
+            <a:pPr indent="0" marL="0">
+              <a:buNone/>
+            </a:pPr>
+            <a:r>
+              <a:rPr lang="en-US" sz="800" i="1" dirty="0">
+                <a:solidFill>
+                  <a:srgbClr val="5B6485"/>
+                </a:solidFill>
+                <a:latin typeface="Calibri" pitchFamily="34" charset="0"/>
+                <a:ea typeface="Calibri" pitchFamily="34" charset="-122"/>
+                <a:cs typeface="Calibri" pitchFamily="34" charset="-120"/>
+              </a:rPr>
+              <a:t>https://maonline.jp/news/20231013b   ·   retrieved 7 Jun 2026</a:t>
+            </a:r>
+            <a:endParaRPr lang="en-US" sz="800" dirty="0"/>
+          </a:p>
+        </ns0:txBody>
+      </ns0:sp>
+      <ns0:sp>
+        <ns0:nvSpPr>
+          <ns0:cNvPr id="26" name="Shape 24"/>
+          <ns0:cNvSpPr/>
+          <ns0:nvPr/>
+        </ns0:nvSpPr>
+        <ns0:spPr>
+          <a:xfrm>
+            <a:off x="548640" y="5285232"/>
+            <a:ext cx="11091672" cy="1078992"/>
+          </a:xfrm>
+          <a:prstGeom prst="roundRect">
+            <a:avLst>
+              <a:gd name="adj" fmla="val 6780"/>
+            </a:avLst>
+          </a:prstGeom>
+          <a:solidFill>
+            <a:srgbClr val="F4F6FB"/>
+          </a:solidFill>
+          <a:ln w="12700">
+            <a:solidFill>
+              <a:srgbClr val="DDE3F0"/>
+            </a:solidFill>
+            <a:prstDash val="solid"/>
+          </a:ln>
+        </ns0:spPr>
+        <ns0:txBody>
+          <a:bodyPr/>
+          <a:p/>
+        </ns0:txBody>
+      </ns0:sp>
+      <ns0:sp>
+        <ns0:nvSpPr>
+          <ns0:cNvPr id="27" name="Shape 25"/>
+          <ns0:cNvSpPr/>
+          <ns0:nvPr/>
+        </ns0:nvSpPr>
+        <ns0:spPr>
+          <a:xfrm>
+            <a:off x="548640" y="5285232"/>
+            <a:ext cx="91440" cy="1078992"/>
+          </a:xfrm>
+          <a:prstGeom prst="roundRect">
+            <a:avLst>
+              <a:gd name="adj" fmla="val 60000"/>
+            </a:avLst>
+          </a:prstGeom>
+          <a:solidFill>
+            <a:srgbClr val="C8A951"/>
+          </a:solidFill>
+          <a:ln/>
+        </ns0:spPr>
+        <ns0:txBody>
+          <a:bodyPr/>
+          <a:p/>
+        </ns0:txBody>
+      </ns0:sp>
+      <ns0:sp>
+        <ns0:nvSpPr>
+          <ns0:cNvPr id="28" name="Text 26"/>
+          <ns0:cNvSpPr/>
+          <ns0:nvPr/>
+        </ns0:nvSpPr>
+        <ns0:spPr>
+          <a:xfrm>
+            <a:off x="868680" y="5376672"/>
+            <a:ext cx="10515600" cy="914400"/>
+          </a:xfrm>
+          <a:prstGeom prst="rect">
+            <a:avLst/>
+          </a:prstGeom>
+          <a:noFill/>
+          <a:ln/>
+        </ns0:spPr>
+        <ns0:txBody>
+          <a:bodyPr wrap="square" lIns="0" tIns="0" rIns="0" bIns="0" rtlCol="0" anchor="ctr"/>
+          <a:lstStyle/>
+          <a:p>
+            <a:r>
+              <a:rPr sz="850"/>
+              <a:t>Reported / estimated / to be verified in DD: founder / related-holder stake, segment margins, peer multiples, investment-securities mark, FY2026E guidance and Akisoku impact. Peer multiples: yfinance snapshots, 7-Jun-2026. Precedent premia — SECOM/ITOCHU notice (5-Sep-2024): secom.co.jp/english/ir/lib_2024/notice20240905-1.pdf · Topcon disclosure (29-Jul-2025): global.topcon.com/invest/wp-content/uploads/library/financial/2025/release_20250729_01_EN.pdf · M&amp;A Online (Tecnos 4-Feb-2025; Kaonavi 13-Feb-2025).</a:t>
+            </a:r>
+          </a:p>
+        </ns0:txBody>
+      </ns0:sp>
+      <ns0:sp>
+        <ns0:nvSpPr>
+          <ns0:cNvPr id="29" name="Text 27"/>
+          <ns0:cNvSpPr/>
+          <ns0:nvPr/>
+        </ns0:nvSpPr>
+        <ns0:spPr>
+          <a:xfrm>
+            <a:off x="548640" y="6455664"/>
+            <a:ext cx="7315200" cy="274320"/>
+          </a:xfrm>
+          <a:prstGeom prst="rect">
+            <a:avLst/>
+          </a:prstGeom>
+          <a:noFill/>
+          <a:ln/>
+        </ns0:spPr>
+        <ns0:txBody>
+          <a:bodyPr wrap="square" lIns="0" tIns="0" rIns="0" bIns="0" rtlCol="0" anchor="ctr"/>
+          <a:lstStyle/>
+          <a:p>
+            <a:pPr algn="l" indent="0" marL="0">
+              <a:buNone/>
+            </a:pPr>
+            <a:r>
+              <a:rPr lang="en-US" sz="850" dirty="0">
+                <a:solidFill>
+                  <a:srgbClr val="8A93B2"/>
+                </a:solidFill>
+                <a:latin typeface="Calibri" pitchFamily="34" charset="0"/>
+                <a:ea typeface="Calibri" pitchFamily="34" charset="-122"/>
+                <a:cs typeface="Calibri" pitchFamily="34" charset="-120"/>
+              </a:rPr>
+              <a:t>Project Measure  ·  Strictly Private &amp; Confidential</a:t>
+            </a:r>
+            <a:endParaRPr lang="en-US" sz="850" dirty="0"/>
+          </a:p>
+        </ns0:txBody>
+      </ns0:sp>
+      <ns0:sp>
+        <ns0:nvSpPr>
+          <ns0:cNvPr id="30" name="Text 28"/>
+          <ns0:cNvSpPr/>
+          <ns0:nvPr/>
+        </ns0:nvSpPr>
+        <ns0:spPr>
+          <a:xfrm>
+            <a:off x="11338560" y="6455664"/>
+            <a:ext cx="365760" cy="274320"/>
+          </a:xfrm>
+          <a:prstGeom prst="rect">
+            <a:avLst/>
+          </a:prstGeom>
+          <a:noFill/>
+          <a:ln/>
+        </ns0:spPr>
+        <ns0:txBody>
+          <a:bodyPr wrap="square" lIns="0" tIns="0" rIns="0" bIns="0" rtlCol="0" anchor="ctr"/>
+          <a:lstStyle/>
+          <a:p>
+            <a:r>
+              <a:rPr sz="750"/>
+              <a:t>20</a:t>
+            </a:r>
           </a:p>
         </ns0:txBody>
       </ns0:sp>
@@ -23520,7 +25320,7 @@
                 <a:ea typeface="Georgia" pitchFamily="34" charset="-122"/>
                 <a:cs typeface="Georgia" pitchFamily="34" charset="-120"/>
               </a:rPr>
-              <a:t>Defensive, recurring core</a:t>
+              <a:t>Defensive, sticky core</a:t>
             </a:r>
             <a:endParaRPr lang="en-US" sz="1450" dirty="0"/>
           </a:p>
@@ -23562,7 +25362,7 @@
                 <a:ea typeface="Calibri" pitchFamily="34" charset="-122"/>
                 <a:cs typeface="Calibri" pitchFamily="34" charset="-120"/>
               </a:rPr>
-              <a:t>The Public segment (surveying &amp; civil-engineering software for licensed land/house surveyors and government) is sticky, budget-linked and runs at a ~26% segment margin — a genuine cash cow underpinning downside protection.</a:t>
+              <a:t>The Public segment (surveying &amp; civil-engineering software for licensed land/house surveyors and government) is sticky and budget-linked, at a ~26% segment margin (recurring mix to verify) — a genuine cash cow underpinning downside protection.</a:t>
             </a:r>
             <a:endParaRPr lang="en-US" sz="1080" dirty="0"/>
           </a:p>
@@ -25335,7 +27135,7 @@
                 <a:ea typeface="Calibri" pitchFamily="34" charset="-122"/>
                 <a:cs typeface="Calibri" pitchFamily="34" charset="-120"/>
               </a:rPr>
-              <a:t>Largest holder</a:t>
+              <a:t>Largest holders</a:t>
             </a:r>
             <a:endParaRPr lang="en-US" sz="1030" dirty="0"/>
           </a:p>
@@ -25374,7 +27174,7 @@
                 <a:ea typeface="Calibri" pitchFamily="34" charset="-122"/>
                 <a:cs typeface="Calibri" pitchFamily="34" charset="-120"/>
               </a:rPr>
-              <a:t>Founder family ~18.5%</a:t>
+              <a:t>Founder / related ~18.5% (reported)</a:t>
             </a:r>
             <a:endParaRPr lang="en-US" sz="1030" dirty="0"/>
           </a:p>
@@ -28367,7 +30167,7 @@
                 <a:ea typeface="Calibri" pitchFamily="34" charset="-122"/>
                 <a:cs typeface="Calibri" pitchFamily="34" charset="-120"/>
               </a:rPr>
-              <a:t>Autonomous fleets require continuously-maintained high-precision maps — a recurring data need.</a:t>
+              <a:t>Autonomous fleets require continuously-maintained high-precision maps — a potential recurring data need.</a:t>
             </a:r>
             <a:endParaRPr lang="en-US" sz="1050" dirty="0"/>
           </a:p>

</xml_diff>

<commit_message>
docs(aisan_lbo_case): second review pass — Excel print layout, neutral wording, log accuracy
Excel (gitignored *.xlsx): fix print/PDF layout of round-4 additions —
segment table (merge margin D:E & value-up G:J, shorten headers), cash
table (wrap headers, shorten case labels), tighten Assumptions notes so
they stop clipping the right block; all 8 tabs now render to 8 clean pages.

PPTX: soften "fraud" -> "investigation / special probe" (match FACT_CHECK
"suspected misconduct"); keep "suspected forgery & concealment" per IR
disclosure; shorten Slide 2 cash caveat so bottom bullet isn't cut.

Docs: update current-state refs to 20 slides / 446 formulas / Source
Appendix Slide 20; keep dated round logs as historical record; add round-5
entries to HANDOFF §5 and PROGRESS.

Co-Authored-By: Claude Opus 4.8 <noreply@anthropic.com>
</commit_message>
<xml_diff>
--- a/aisan_lbo_case/docs/AISAN_4667_Take_Private_Case_Study.pptx
+++ b/aisan_lbo_case/docs/AISAN_4667_Take_Private_Case_Study.pptx
@@ -18165,7 +18165,7 @@
                 <a:ea typeface="Calibri" pitchFamily="34" charset="-122"/>
                 <a:cs typeface="Calibri" pitchFamily="34" charset="-120"/>
               </a:rPr>
-              <a:t>Subsidiary fraud probe (GATING)</a:t>
+              <a:t>Subsidiary investigation (GATING)</a:t>
             </a:r>
             <a:endParaRPr lang="en-US" sz="1150" dirty="0"/>
           </a:p>
@@ -19564,7 +19564,7 @@
                 <a:ea typeface="Calibri" pitchFamily="34" charset="-122"/>
                 <a:cs typeface="Calibri" pitchFamily="34" charset="-120"/>
               </a:rPr>
-              <a:t>An unresolved fraud probe at a 100%-owned subsidiary overrides the investment case until cleared</a:t>
+              <a:t>An unresolved investigation at a 100%-owned subsidiary overrides the investment case until cleared</a:t>
             </a:r>
             <a:endParaRPr lang="en-US" sz="1250" dirty="0"/>
           </a:p>
@@ -20602,7 +20602,7 @@
                 <a:ea typeface="Calibri" pitchFamily="34" charset="-122"/>
                 <a:cs typeface="Calibri" pitchFamily="34" charset="-120"/>
               </a:rPr>
-              <a:t>The post-news reference price is already fraud-depressed — premium must re-base on a clean price</a:t>
+              <a:t>The post-news reference price is already investigation-depressed — premium must re-base on a clean price</a:t>
             </a:r>
             <a:endParaRPr lang="en-US" sz="1000" dirty="0"/>
           </a:p>
@@ -21360,7 +21360,7 @@
                 <a:ea typeface="Georgia" pitchFamily="34" charset="-122"/>
                 <a:cs typeface="Georgia" pitchFamily="34" charset="-120"/>
               </a:rPr>
-              <a:t>but a live fraud investigation and sub-hurdle returns mean we should not bid now.</a:t>
+              <a:t>but a live investigation and sub-hurdle returns mean we should not bid now.</a:t>
             </a:r>
             <a:endParaRPr lang="en-US" sz="2500" dirty="0"/>
           </a:p>
@@ -22229,7 +22229,7 @@
                 <a:ea typeface="Calibri" pitchFamily="34" charset="-122"/>
                 <a:cs typeface="Calibri" pitchFamily="34" charset="-120"/>
               </a:rPr>
-              <a:t>Fundamentally interesting, but an active subsidiary fraud investigation and sub-hurdle returns make a bid premature</a:t>
+              <a:t>Fundamentally interesting, but an active subsidiary investigation and sub-hurdle returns make a bid premature</a:t>
             </a:r>
             <a:endParaRPr lang="en-US" sz="1250" dirty="0"/>
           </a:p>
@@ -23001,7 +23001,7 @@
                 <a:ea typeface="Georgia" pitchFamily="34" charset="-122"/>
                 <a:cs typeface="Georgia" pitchFamily="34" charset="-120"/>
               </a:rPr>
-              <a:t>Fraud probe</a:t>
+              <a:t>Special probe</a:t>
             </a:r>
             <a:endParaRPr lang="en-US" sz="2300" dirty="0"/>
           </a:p>
@@ -23417,7 +23417,7 @@
                 <a:ea typeface="Calibri" pitchFamily="34" charset="-122"/>
                 <a:cs typeface="Calibri" pitchFamily="34" charset="-120"/>
               </a:rPr>
-              <a:t>Over-capitalised balance sheet: ~¥4.1bn net cash — base case assumes deployment; returns fall to ~12% / ~8% if cash is retained / trapped (DD item)</a:t>
+              <a:t>Over-capitalised balance sheet: ~¥4.1bn net cash; deployment assumed in base case — returns fall to ~12%/~8% if not (DD item)</a:t>
             </a:r>
             <a:endParaRPr lang="en-US" sz="1150" dirty="0"/>
           </a:p>
@@ -23987,7 +23987,7 @@
                 <a:ea typeface="Calibri" pitchFamily="34" charset="-122"/>
                 <a:cs typeface="Calibri" pitchFamily="34" charset="-120"/>
               </a:rPr>
-              <a:t>  —  subsidiary fraud probe: scope, trigger, committee composition</a:t>
+              <a:t>  —  subsidiary investigation (suspected misconduct): scope, trigger, committee composition</a:t>
             </a:r>
             <a:endParaRPr lang="en-US" sz="970" dirty="0"/>
           </a:p>

</xml_diff>

<commit_message>
docs(aisan_lbo_case): external-facing wording in Excel + slide hedging + log accuracy
- Excel: Assumptions!B5 "post-fraud-news" -> "post-investigation disclosure";
  Scenarios!G7 drop internal "treasury-share correction" narrative (recalc
  446 formulas, 0 errors, values unchanged).
- PPTX: prefix standalone "forgery & concealment" with "suspected" on slides
  2 and 18 (match the cautious FACT_CHECK framing).
- Docs: fix remaining current-state "19 slides" -> 20 (HANDOFF §9, FACT_CHECK);
  dated round logs kept as historical record.

Co-Authored-By: Claude Opus 4.8 <noreply@anthropic.com>
</commit_message>
<xml_diff>
--- a/aisan_lbo_case/docs/AISAN_4667_Take_Private_Case_Study.pptx
+++ b/aisan_lbo_case/docs/AISAN_4667_Take_Private_Case_Study.pptx
@@ -20224,7 +20224,7 @@
                 <a:ea typeface="Calibri" pitchFamily="34" charset="-122"/>
                 <a:cs typeface="Calibri" pitchFamily="34" charset="-120"/>
               </a:rPr>
-              <a:t>Further forged documents and concealment of inventory losses / unpaid debts identified.</a:t>
+              <a:t>Further suspected forged documents and concealment of inventory losses / unpaid debts.</a:t>
             </a:r>
             <a:endParaRPr lang="en-US" sz="970" dirty="0"/>
           </a:p>
@@ -20623,7 +20623,7 @@
                 <a:ea typeface="Calibri" pitchFamily="34" charset="-122"/>
                 <a:cs typeface="Calibri" pitchFamily="34" charset="-120"/>
               </a:rPr>
-              <a:t>Forgery at a recently-bought subsidiary signals weak group controls &amp; integration DD</a:t>
+              <a:t>Suspected forgery at a recently-bought subsidiary signals weak group controls &amp; integration DD</a:t>
             </a:r>
             <a:endParaRPr lang="en-US" sz="1000" dirty="0"/>
           </a:p>
@@ -23605,7 +23605,7 @@
                 <a:ea typeface="Calibri" pitchFamily="34" charset="-122"/>
                 <a:cs typeface="Calibri" pitchFamily="34" charset="-120"/>
               </a:rPr>
-              <a:t>Subsidiary (Akisoku) under special investigation — forgery &amp; concealment</a:t>
+              <a:t>Subsidiary (Akisoku) under special investigation — suspected forgery / concealment</a:t>
             </a:r>
             <a:endParaRPr lang="en-US" sz="1150" dirty="0"/>
           </a:p>

</xml_diff>